<commit_message>
feat: completar materiales semana 05 (clase 02 y 03) y nuevos componentes agénticos
</commit_message>
<xml_diff>
--- a/clases/semana-05/02/ppt/Clase-14-Persistencia-Modelado.pptx
+++ b/clases/semana-05/02/ppt/Clase-14-Persistencia-Modelado.pptx
@@ -68,9 +68,12 @@
     <p:sldId id="316" r:id="rId62"/>
     <p:sldId id="317" r:id="rId63"/>
     <p:sldId id="318" r:id="rId64"/>
+    <p:sldId id="319" r:id="rId65"/>
+    <p:sldId id="320" r:id="rId66"/>
+    <p:sldId id="321" r:id="rId67"/>
   </p:sldIdLst>
   <p:notesMasterIdLst>
-    <p:notesMasterId r:id="rId65"/>
+    <p:notesMasterId r:id="rId68"/>
   </p:notesMasterIdLst>
   <p:sldSz cx="12192000" cy="6858000"/>
   <p:notesSz cx="6858000" cy="12192000"/>
@@ -5798,6 +5801,270 @@
 </p:notes>
 </file>
 
+<file path=ppt/notesSlides/notesSlide64.xml><?xml version="1.0" encoding="utf-8"?>
+<p:notes xmlns:a="http://schemas.openxmlformats.org/drawingml/2006/main" xmlns:r="http://schemas.openxmlformats.org/officeDocument/2006/relationships" xmlns:p="http://schemas.openxmlformats.org/presentationml/2006/main">
+  <p:cSld>
+    <p:spTree>
+      <p:nvGrpSpPr>
+        <p:cNvPr id="1" name=""/>
+        <p:cNvGrpSpPr/>
+        <p:nvPr/>
+      </p:nvGrpSpPr>
+      <p:grpSpPr>
+        <a:xfrm>
+          <a:off x="0" y="0"/>
+          <a:ext cx="0" cy="0"/>
+          <a:chOff x="0" y="0"/>
+          <a:chExt cx="0" cy="0"/>
+        </a:xfrm>
+      </p:grpSpPr>
+      <p:sp>
+        <p:nvSpPr>
+          <p:cNvPr id="2" name="Slide Image Placeholder 1"/>
+          <p:cNvSpPr>
+            <a:spLocks noGrp="1" noRot="1" noChangeAspect="1"/>
+          </p:cNvSpPr>
+          <p:nvPr>
+            <p:ph type="sldImg"/>
+          </p:nvPr>
+        </p:nvSpPr>
+        <p:spPr/>
+      </p:sp>
+      <p:sp>
+        <p:nvSpPr>
+          <p:cNvPr id="3" name="Notes Placeholder 2"/>
+          <p:cNvSpPr>
+            <a:spLocks noGrp="1"/>
+          </p:cNvSpPr>
+          <p:nvPr>
+            <p:ph type="body" idx="1"/>
+          </p:nvPr>
+        </p:nvSpPr>
+        <p:spPr/>
+        <p:txBody>
+          <a:bodyPr/>
+          <a:lstStyle/>
+          <a:p>
+            <a:r>
+              <a:rPr lang="en-US" dirty="0"/>
+              <a:t/>
+            </a:r>
+            <a:endParaRPr lang="en-US" dirty="0"/>
+          </a:p>
+        </p:txBody>
+      </p:sp>
+      <p:sp>
+        <p:nvSpPr>
+          <p:cNvPr id="4" name="Slide Number Placeholder 3"/>
+          <p:cNvSpPr>
+            <a:spLocks noGrp="1"/>
+          </p:cNvSpPr>
+          <p:nvPr>
+            <p:ph type="sldNum" sz="quarter" idx="10"/>
+          </p:nvPr>
+        </p:nvSpPr>
+        <p:spPr/>
+        <p:txBody>
+          <a:bodyPr/>
+          <a:lstStyle/>
+          <a:p>
+            <a:fld id="{F7021451-1387-4CA6-816F-3879F97B5CBC}" type="slidenum">
+              <a:rPr lang="en-US"/>
+              <a:t>64</a:t>
+            </a:fld>
+            <a:endParaRPr lang="en-US"/>
+          </a:p>
+        </p:txBody>
+      </p:sp>
+    </p:spTree>
+    <p:extLst>
+      <p:ext uri="{BB962C8B-B14F-4D97-AF65-F5344CB8AC3E}">
+        <p14:creationId xmlns:p14="http://schemas.microsoft.com/office/powerpoint/2010/main" val="1024086991"/>
+      </p:ext>
+    </p:extLst>
+  </p:cSld>
+  <p:clrMapOvr>
+    <a:masterClrMapping/>
+  </p:clrMapOvr>
+</p:notes>
+</file>
+
+<file path=ppt/notesSlides/notesSlide65.xml><?xml version="1.0" encoding="utf-8"?>
+<p:notes xmlns:a="http://schemas.openxmlformats.org/drawingml/2006/main" xmlns:r="http://schemas.openxmlformats.org/officeDocument/2006/relationships" xmlns:p="http://schemas.openxmlformats.org/presentationml/2006/main">
+  <p:cSld>
+    <p:spTree>
+      <p:nvGrpSpPr>
+        <p:cNvPr id="1" name=""/>
+        <p:cNvGrpSpPr/>
+        <p:nvPr/>
+      </p:nvGrpSpPr>
+      <p:grpSpPr>
+        <a:xfrm>
+          <a:off x="0" y="0"/>
+          <a:ext cx="0" cy="0"/>
+          <a:chOff x="0" y="0"/>
+          <a:chExt cx="0" cy="0"/>
+        </a:xfrm>
+      </p:grpSpPr>
+      <p:sp>
+        <p:nvSpPr>
+          <p:cNvPr id="2" name="Slide Image Placeholder 1"/>
+          <p:cNvSpPr>
+            <a:spLocks noGrp="1" noRot="1" noChangeAspect="1"/>
+          </p:cNvSpPr>
+          <p:nvPr>
+            <p:ph type="sldImg"/>
+          </p:nvPr>
+        </p:nvSpPr>
+        <p:spPr/>
+      </p:sp>
+      <p:sp>
+        <p:nvSpPr>
+          <p:cNvPr id="3" name="Notes Placeholder 2"/>
+          <p:cNvSpPr>
+            <a:spLocks noGrp="1"/>
+          </p:cNvSpPr>
+          <p:nvPr>
+            <p:ph type="body" idx="1"/>
+          </p:nvPr>
+        </p:nvSpPr>
+        <p:spPr/>
+        <p:txBody>
+          <a:bodyPr/>
+          <a:lstStyle/>
+          <a:p>
+            <a:r>
+              <a:rPr lang="en-US" dirty="0"/>
+              <a:t/>
+            </a:r>
+            <a:endParaRPr lang="en-US" dirty="0"/>
+          </a:p>
+        </p:txBody>
+      </p:sp>
+      <p:sp>
+        <p:nvSpPr>
+          <p:cNvPr id="4" name="Slide Number Placeholder 3"/>
+          <p:cNvSpPr>
+            <a:spLocks noGrp="1"/>
+          </p:cNvSpPr>
+          <p:nvPr>
+            <p:ph type="sldNum" sz="quarter" idx="10"/>
+          </p:nvPr>
+        </p:nvSpPr>
+        <p:spPr/>
+        <p:txBody>
+          <a:bodyPr/>
+          <a:lstStyle/>
+          <a:p>
+            <a:fld id="{F7021451-1387-4CA6-816F-3879F97B5CBC}" type="slidenum">
+              <a:rPr lang="en-US"/>
+              <a:t>65</a:t>
+            </a:fld>
+            <a:endParaRPr lang="en-US"/>
+          </a:p>
+        </p:txBody>
+      </p:sp>
+    </p:spTree>
+    <p:extLst>
+      <p:ext uri="{BB962C8B-B14F-4D97-AF65-F5344CB8AC3E}">
+        <p14:creationId xmlns:p14="http://schemas.microsoft.com/office/powerpoint/2010/main" val="1024086991"/>
+      </p:ext>
+    </p:extLst>
+  </p:cSld>
+  <p:clrMapOvr>
+    <a:masterClrMapping/>
+  </p:clrMapOvr>
+</p:notes>
+</file>
+
+<file path=ppt/notesSlides/notesSlide66.xml><?xml version="1.0" encoding="utf-8"?>
+<p:notes xmlns:a="http://schemas.openxmlformats.org/drawingml/2006/main" xmlns:r="http://schemas.openxmlformats.org/officeDocument/2006/relationships" xmlns:p="http://schemas.openxmlformats.org/presentationml/2006/main">
+  <p:cSld>
+    <p:spTree>
+      <p:nvGrpSpPr>
+        <p:cNvPr id="1" name=""/>
+        <p:cNvGrpSpPr/>
+        <p:nvPr/>
+      </p:nvGrpSpPr>
+      <p:grpSpPr>
+        <a:xfrm>
+          <a:off x="0" y="0"/>
+          <a:ext cx="0" cy="0"/>
+          <a:chOff x="0" y="0"/>
+          <a:chExt cx="0" cy="0"/>
+        </a:xfrm>
+      </p:grpSpPr>
+      <p:sp>
+        <p:nvSpPr>
+          <p:cNvPr id="2" name="Slide Image Placeholder 1"/>
+          <p:cNvSpPr>
+            <a:spLocks noGrp="1" noRot="1" noChangeAspect="1"/>
+          </p:cNvSpPr>
+          <p:nvPr>
+            <p:ph type="sldImg"/>
+          </p:nvPr>
+        </p:nvSpPr>
+        <p:spPr/>
+      </p:sp>
+      <p:sp>
+        <p:nvSpPr>
+          <p:cNvPr id="3" name="Notes Placeholder 2"/>
+          <p:cNvSpPr>
+            <a:spLocks noGrp="1"/>
+          </p:cNvSpPr>
+          <p:nvPr>
+            <p:ph type="body" idx="1"/>
+          </p:nvPr>
+        </p:nvSpPr>
+        <p:spPr/>
+        <p:txBody>
+          <a:bodyPr/>
+          <a:lstStyle/>
+          <a:p>
+            <a:r>
+              <a:rPr lang="en-US" dirty="0"/>
+              <a:t/>
+            </a:r>
+            <a:endParaRPr lang="en-US" dirty="0"/>
+          </a:p>
+        </p:txBody>
+      </p:sp>
+      <p:sp>
+        <p:nvSpPr>
+          <p:cNvPr id="4" name="Slide Number Placeholder 3"/>
+          <p:cNvSpPr>
+            <a:spLocks noGrp="1"/>
+          </p:cNvSpPr>
+          <p:nvPr>
+            <p:ph type="sldNum" sz="quarter" idx="10"/>
+          </p:nvPr>
+        </p:nvSpPr>
+        <p:spPr/>
+        <p:txBody>
+          <a:bodyPr/>
+          <a:lstStyle/>
+          <a:p>
+            <a:fld id="{F7021451-1387-4CA6-816F-3879F97B5CBC}" type="slidenum">
+              <a:rPr lang="en-US"/>
+              <a:t>66</a:t>
+            </a:fld>
+            <a:endParaRPr lang="en-US"/>
+          </a:p>
+        </p:txBody>
+      </p:sp>
+    </p:spTree>
+    <p:extLst>
+      <p:ext uri="{BB962C8B-B14F-4D97-AF65-F5344CB8AC3E}">
+        <p14:creationId xmlns:p14="http://schemas.microsoft.com/office/powerpoint/2010/main" val="1024086991"/>
+      </p:ext>
+    </p:extLst>
+  </p:cSld>
+  <p:clrMapOvr>
+    <a:masterClrMapping/>
+  </p:clrMapOvr>
+</p:notes>
+</file>
+
 <file path=ppt/notesSlides/notesSlide7.xml><?xml version="1.0" encoding="utf-8"?>
 <p:notes xmlns:a="http://schemas.openxmlformats.org/drawingml/2006/main" xmlns:r="http://schemas.openxmlformats.org/officeDocument/2006/relationships" xmlns:p="http://schemas.openxmlformats.org/presentationml/2006/main">
   <p:cSld>
@@ -56001,6 +56268,2117 @@
     <p:bg>
       <p:bgPr>
         <a:solidFill>
+          <a:srgbClr val="F8F3EC"/>
+        </a:solidFill>
+      </p:bgPr>
+    </p:bg>
+    <p:spTree>
+      <p:nvGrpSpPr>
+        <p:cNvPr id="1" name=""/>
+        <p:cNvGrpSpPr/>
+        <p:nvPr/>
+      </p:nvGrpSpPr>
+      <p:grpSpPr>
+        <a:xfrm>
+          <a:off x="0" y="0"/>
+          <a:ext cx="0" cy="0"/>
+          <a:chOff x="0" y="0"/>
+          <a:chExt cx="0" cy="0"/>
+        </a:xfrm>
+      </p:grpSpPr>
+      <p:sp>
+        <p:nvSpPr>
+          <p:cNvPr id="2" name="Shape 0"/>
+          <p:cNvSpPr/>
+          <p:nvPr/>
+        </p:nvSpPr>
+        <p:spPr>
+          <a:xfrm>
+            <a:off x="0" y="0"/>
+            <a:ext cx="12191695" cy="146304"/>
+          </a:xfrm>
+          <a:prstGeom prst="rect">
+            <a:avLst/>
+          </a:prstGeom>
+          <a:solidFill>
+            <a:srgbClr val="102A43"/>
+          </a:solidFill>
+          <a:ln w="12700">
+            <a:solidFill>
+              <a:srgbClr val="102A43"/>
+            </a:solidFill>
+            <a:prstDash val="solid"/>
+          </a:ln>
+        </p:spPr>
+      </p:sp>
+      <p:sp>
+        <p:nvSpPr>
+          <p:cNvPr id="3" name="Text 1"/>
+          <p:cNvSpPr/>
+          <p:nvPr/>
+        </p:nvSpPr>
+        <p:spPr>
+          <a:xfrm>
+            <a:off x="9829800" y="237744"/>
+            <a:ext cx="1737360" cy="640080"/>
+          </a:xfrm>
+          <a:prstGeom prst="rect">
+            <a:avLst/>
+          </a:prstGeom>
+          <a:noFill/>
+          <a:ln/>
+        </p:spPr>
+        <p:txBody>
+          <a:bodyPr wrap="square" lIns="0" tIns="0" rIns="0" bIns="0" rtlCol="0" anchor="ctr"/>
+          <a:lstStyle/>
+          <a:p>
+            <a:pPr algn="r" indent="0" marL="0">
+              <a:buNone/>
+            </a:pPr>
+            <a:r>
+              <a:rPr lang="en-US" sz="2800" b="1" dirty="0">
+                <a:solidFill>
+                  <a:srgbClr val="EADFD0"/>
+                </a:solidFill>
+                <a:latin typeface="Aptos Display" pitchFamily="34" charset="0"/>
+                <a:ea typeface="Aptos Display" pitchFamily="34" charset="-122"/>
+                <a:cs typeface="Aptos Display" pitchFamily="34" charset="-120"/>
+              </a:rPr>
+              <a:t>63</a:t>
+            </a:r>
+            <a:endParaRPr lang="en-US" sz="2800" dirty="0"/>
+          </a:p>
+        </p:txBody>
+      </p:sp>
+      <p:sp>
+        <p:nvSpPr>
+          <p:cNvPr id="4" name="Shape 2"/>
+          <p:cNvSpPr/>
+          <p:nvPr/>
+        </p:nvSpPr>
+        <p:spPr>
+          <a:xfrm>
+            <a:off x="658368" y="475488"/>
+            <a:ext cx="1993392" cy="310896"/>
+          </a:xfrm>
+          <a:prstGeom prst="roundRect">
+            <a:avLst>
+              <a:gd name="adj" fmla="val 14706"/>
+            </a:avLst>
+          </a:prstGeom>
+          <a:solidFill>
+            <a:srgbClr val="D62027"/>
+          </a:solidFill>
+          <a:ln w="12700">
+            <a:solidFill>
+              <a:srgbClr val="D62027"/>
+            </a:solidFill>
+            <a:prstDash val="solid"/>
+          </a:ln>
+        </p:spPr>
+      </p:sp>
+      <p:sp>
+        <p:nvSpPr>
+          <p:cNvPr id="5" name="Text 3"/>
+          <p:cNvSpPr/>
+          <p:nvPr/>
+        </p:nvSpPr>
+        <p:spPr>
+          <a:xfrm>
+            <a:off x="768096" y="512064"/>
+            <a:ext cx="1773936" cy="201168"/>
+          </a:xfrm>
+          <a:prstGeom prst="rect">
+            <a:avLst/>
+          </a:prstGeom>
+          <a:noFill/>
+          <a:ln/>
+        </p:spPr>
+        <p:txBody>
+          <a:bodyPr wrap="square" lIns="0" tIns="0" rIns="0" bIns="0" rtlCol="0" anchor="ctr"/>
+          <a:lstStyle/>
+          <a:p>
+            <a:pPr algn="ctr" indent="0" marL="0">
+              <a:buNone/>
+            </a:pPr>
+            <a:r>
+              <a:rPr lang="en-US" sz="950" b="1" dirty="0">
+                <a:solidFill>
+                  <a:srgbClr val="FFFFFF"/>
+                </a:solidFill>
+                <a:latin typeface="Aptos" pitchFamily="34" charset="0"/>
+                <a:ea typeface="Aptos" pitchFamily="34" charset="-122"/>
+                <a:cs typeface="Aptos" pitchFamily="34" charset="-120"/>
+              </a:rPr>
+              <a:t>Clase 14 · Cierre</a:t>
+            </a:r>
+            <a:endParaRPr lang="en-US" sz="950" dirty="0"/>
+          </a:p>
+        </p:txBody>
+      </p:sp>
+      <p:sp>
+        <p:nvSpPr>
+          <p:cNvPr id="6" name="Shape 4"/>
+          <p:cNvSpPr/>
+          <p:nvPr/>
+        </p:nvSpPr>
+        <p:spPr>
+          <a:xfrm>
+            <a:off x="10094976" y="859536"/>
+            <a:ext cx="987552" cy="749808"/>
+          </a:xfrm>
+          <a:prstGeom prst="ellipse">
+            <a:avLst/>
+          </a:prstGeom>
+          <a:solidFill>
+            <a:srgbClr val="EDE6DA"/>
+          </a:solidFill>
+          <a:ln w="12700">
+            <a:solidFill>
+              <a:srgbClr val="EDE6DA"/>
+            </a:solidFill>
+            <a:prstDash val="solid"/>
+          </a:ln>
+        </p:spPr>
+      </p:sp>
+      <p:pic>
+        <p:nvPicPr>
+          <p:cNvPr id="7" name="Image 0" descr="C:\Users\Diego Obando\dev\pro301-taller-de-aplicaciones-para-internet\.agent\skills\slides-aiep\assets\logo-aiep-mark.png">    </p:cNvPr>
+          <p:cNvPicPr>
+            <a:picLocks noChangeAspect="1"/>
+          </p:cNvPicPr>
+          <p:nvPr/>
+        </p:nvPicPr>
+        <p:blipFill>
+          <a:blip r:embed="rId1"/>
+          <a:stretch>
+            <a:fillRect/>
+          </a:stretch>
+        </p:blipFill>
+        <p:spPr>
+          <a:xfrm>
+            <a:off x="10342310" y="1060704"/>
+            <a:ext cx="492884" cy="310896"/>
+          </a:xfrm>
+          <a:prstGeom prst="rect">
+            <a:avLst/>
+          </a:prstGeom>
+        </p:spPr>
+      </p:pic>
+      <p:sp>
+        <p:nvSpPr>
+          <p:cNvPr id="8" name="Text 5"/>
+          <p:cNvSpPr/>
+          <p:nvPr/>
+        </p:nvSpPr>
+        <p:spPr>
+          <a:xfrm>
+            <a:off x="658368" y="859536"/>
+            <a:ext cx="8138160" cy="603504"/>
+          </a:xfrm>
+          <a:prstGeom prst="rect">
+            <a:avLst/>
+          </a:prstGeom>
+          <a:noFill/>
+          <a:ln/>
+        </p:spPr>
+        <p:txBody>
+          <a:bodyPr wrap="square" lIns="0" tIns="0" rIns="0" bIns="0" rtlCol="0" anchor="ctr"/>
+          <a:lstStyle/>
+          <a:p>
+            <a:pPr indent="0" marL="0">
+              <a:buNone/>
+            </a:pPr>
+            <a:r>
+              <a:rPr lang="en-US" sz="2400" b="1" dirty="0">
+                <a:solidFill>
+                  <a:srgbClr val="102A43"/>
+                </a:solidFill>
+                <a:latin typeface="Aptos Display" pitchFamily="34" charset="0"/>
+                <a:ea typeface="Aptos Display" pitchFamily="34" charset="-122"/>
+                <a:cs typeface="Aptos Display" pitchFamily="34" charset="-120"/>
+              </a:rPr>
+              <a:t>Síntesis: Los Cimientos del Backend</a:t>
+            </a:r>
+            <a:endParaRPr lang="en-US" sz="2400" dirty="0"/>
+          </a:p>
+        </p:txBody>
+      </p:sp>
+      <p:sp>
+        <p:nvSpPr>
+          <p:cNvPr id="9" name="Text 6"/>
+          <p:cNvSpPr/>
+          <p:nvPr/>
+        </p:nvSpPr>
+        <p:spPr>
+          <a:xfrm>
+            <a:off x="676656" y="1536192"/>
+            <a:ext cx="8275320" cy="201168"/>
+          </a:xfrm>
+          <a:prstGeom prst="rect">
+            <a:avLst/>
+          </a:prstGeom>
+          <a:noFill/>
+          <a:ln/>
+        </p:spPr>
+        <p:txBody>
+          <a:bodyPr wrap="square" lIns="0" tIns="0" rIns="0" bIns="0" rtlCol="0" anchor="ctr"/>
+          <a:lstStyle/>
+          <a:p>
+            <a:pPr indent="0" marL="0">
+              <a:buNone/>
+            </a:pPr>
+            <a:r>
+              <a:rPr lang="en-US" sz="1060" dirty="0">
+                <a:solidFill>
+                  <a:srgbClr val="52606D"/>
+                </a:solidFill>
+                <a:latin typeface="Aptos" pitchFamily="34" charset="0"/>
+                <a:ea typeface="Aptos" pitchFamily="34" charset="-122"/>
+                <a:cs typeface="Aptos" pitchFamily="34" charset="-120"/>
+              </a:rPr>
+              <a:t>Cierre de Clase · El ciclo de vida del dato</a:t>
+            </a:r>
+            <a:endParaRPr lang="en-US" sz="1060" dirty="0"/>
+          </a:p>
+        </p:txBody>
+      </p:sp>
+      <p:sp>
+        <p:nvSpPr>
+          <p:cNvPr id="10" name="Shape 7"/>
+          <p:cNvSpPr/>
+          <p:nvPr/>
+        </p:nvSpPr>
+        <p:spPr>
+          <a:xfrm>
+            <a:off x="804672" y="2029968"/>
+            <a:ext cx="4590288" cy="1700784"/>
+          </a:xfrm>
+          <a:prstGeom prst="roundRect">
+            <a:avLst>
+              <a:gd name="adj" fmla="val 3226"/>
+            </a:avLst>
+          </a:prstGeom>
+          <a:solidFill>
+            <a:srgbClr val="FFFFFF"/>
+          </a:solidFill>
+          <a:ln w="12700">
+            <a:solidFill>
+              <a:srgbClr val="D8CFC4"/>
+            </a:solidFill>
+            <a:prstDash val="solid"/>
+          </a:ln>
+        </p:spPr>
+      </p:sp>
+      <p:sp>
+        <p:nvSpPr>
+          <p:cNvPr id="11" name="Shape 8"/>
+          <p:cNvSpPr/>
+          <p:nvPr/>
+        </p:nvSpPr>
+        <p:spPr>
+          <a:xfrm>
+            <a:off x="896112" y="2157984"/>
+            <a:ext cx="64008" cy="1444752"/>
+          </a:xfrm>
+          <a:prstGeom prst="rect">
+            <a:avLst/>
+          </a:prstGeom>
+          <a:solidFill>
+            <a:srgbClr val="102A43"/>
+          </a:solidFill>
+          <a:ln w="12700">
+            <a:solidFill>
+              <a:srgbClr val="102A43"/>
+            </a:solidFill>
+            <a:prstDash val="solid"/>
+          </a:ln>
+        </p:spPr>
+      </p:sp>
+      <p:sp>
+        <p:nvSpPr>
+          <p:cNvPr id="12" name="Text 9"/>
+          <p:cNvSpPr/>
+          <p:nvPr/>
+        </p:nvSpPr>
+        <p:spPr>
+          <a:xfrm>
+            <a:off x="1060704" y="2139696"/>
+            <a:ext cx="4242816" cy="310896"/>
+          </a:xfrm>
+          <a:prstGeom prst="rect">
+            <a:avLst/>
+          </a:prstGeom>
+          <a:noFill/>
+          <a:ln/>
+        </p:spPr>
+        <p:txBody>
+          <a:bodyPr wrap="square" lIns="0" tIns="0" rIns="0" bIns="0" rtlCol="0" anchor="ctr"/>
+          <a:lstStyle/>
+          <a:p>
+            <a:pPr indent="0" marL="0">
+              <a:buNone/>
+            </a:pPr>
+            <a:r>
+              <a:rPr lang="en-US" sz="1420" b="1" dirty="0">
+                <a:solidFill>
+                  <a:srgbClr val="102A43"/>
+                </a:solidFill>
+                <a:latin typeface="Aptos Display" pitchFamily="34" charset="0"/>
+                <a:ea typeface="Aptos Display" pitchFamily="34" charset="-122"/>
+                <a:cs typeface="Aptos Display" pitchFamily="34" charset="-120"/>
+              </a:rPr>
+              <a:t>Entidades</a:t>
+            </a:r>
+            <a:endParaRPr lang="en-US" sz="1420" dirty="0"/>
+          </a:p>
+        </p:txBody>
+      </p:sp>
+      <p:sp>
+        <p:nvSpPr>
+          <p:cNvPr id="13" name="Text 10"/>
+          <p:cNvSpPr/>
+          <p:nvPr/>
+        </p:nvSpPr>
+        <p:spPr>
+          <a:xfrm>
+            <a:off x="1060704" y="2487168"/>
+            <a:ext cx="4242816" cy="1115568"/>
+          </a:xfrm>
+          <a:prstGeom prst="rect">
+            <a:avLst/>
+          </a:prstGeom>
+          <a:noFill/>
+          <a:ln/>
+        </p:spPr>
+        <p:txBody>
+          <a:bodyPr wrap="square" lIns="0" tIns="0" rIns="0" bIns="0" rtlCol="0" anchor="t"/>
+          <a:lstStyle/>
+          <a:p>
+            <a:pPr algn="l" indent="0" marL="0">
+              <a:buNone/>
+            </a:pPr>
+            <a:r>
+              <a:rPr lang="en-US" sz="1080" dirty="0">
+                <a:solidFill>
+                  <a:srgbClr val="243B53"/>
+                </a:solidFill>
+                <a:latin typeface="Aptos" pitchFamily="34" charset="0"/>
+                <a:ea typeface="Aptos" pitchFamily="34" charset="-122"/>
+                <a:cs typeface="Aptos" pitchFamily="34" charset="-120"/>
+              </a:rPr>
+              <a:t>Objetos del negocio con identidad única (Primary Key).</a:t>
+            </a:r>
+            <a:endParaRPr lang="en-US" sz="1080" dirty="0"/>
+          </a:p>
+        </p:txBody>
+      </p:sp>
+      <p:sp>
+        <p:nvSpPr>
+          <p:cNvPr id="14" name="Shape 11"/>
+          <p:cNvSpPr/>
+          <p:nvPr/>
+        </p:nvSpPr>
+        <p:spPr>
+          <a:xfrm>
+            <a:off x="5596128" y="2029968"/>
+            <a:ext cx="4590288" cy="1700784"/>
+          </a:xfrm>
+          <a:prstGeom prst="roundRect">
+            <a:avLst>
+              <a:gd name="adj" fmla="val 3226"/>
+            </a:avLst>
+          </a:prstGeom>
+          <a:solidFill>
+            <a:srgbClr val="FFFFFF"/>
+          </a:solidFill>
+          <a:ln w="12700">
+            <a:solidFill>
+              <a:srgbClr val="D8CFC4"/>
+            </a:solidFill>
+            <a:prstDash val="solid"/>
+          </a:ln>
+        </p:spPr>
+      </p:sp>
+      <p:sp>
+        <p:nvSpPr>
+          <p:cNvPr id="15" name="Shape 12"/>
+          <p:cNvSpPr/>
+          <p:nvPr/>
+        </p:nvSpPr>
+        <p:spPr>
+          <a:xfrm>
+            <a:off x="5687568" y="2157984"/>
+            <a:ext cx="64008" cy="1444752"/>
+          </a:xfrm>
+          <a:prstGeom prst="rect">
+            <a:avLst/>
+          </a:prstGeom>
+          <a:solidFill>
+            <a:srgbClr val="D62027"/>
+          </a:solidFill>
+          <a:ln w="12700">
+            <a:solidFill>
+              <a:srgbClr val="D62027"/>
+            </a:solidFill>
+            <a:prstDash val="solid"/>
+          </a:ln>
+        </p:spPr>
+      </p:sp>
+      <p:sp>
+        <p:nvSpPr>
+          <p:cNvPr id="16" name="Text 13"/>
+          <p:cNvSpPr/>
+          <p:nvPr/>
+        </p:nvSpPr>
+        <p:spPr>
+          <a:xfrm>
+            <a:off x="5852160" y="2139696"/>
+            <a:ext cx="4242816" cy="310896"/>
+          </a:xfrm>
+          <a:prstGeom prst="rect">
+            <a:avLst/>
+          </a:prstGeom>
+          <a:noFill/>
+          <a:ln/>
+        </p:spPr>
+        <p:txBody>
+          <a:bodyPr wrap="square" lIns="0" tIns="0" rIns="0" bIns="0" rtlCol="0" anchor="ctr"/>
+          <a:lstStyle/>
+          <a:p>
+            <a:pPr indent="0" marL="0">
+              <a:buNone/>
+            </a:pPr>
+            <a:r>
+              <a:rPr lang="en-US" sz="1420" b="1" dirty="0">
+                <a:solidFill>
+                  <a:srgbClr val="102A43"/>
+                </a:solidFill>
+                <a:latin typeface="Aptos Display" pitchFamily="34" charset="0"/>
+                <a:ea typeface="Aptos Display" pitchFamily="34" charset="-122"/>
+                <a:cs typeface="Aptos Display" pitchFamily="34" charset="-120"/>
+              </a:rPr>
+              <a:t>Relaciones</a:t>
+            </a:r>
+            <a:endParaRPr lang="en-US" sz="1420" dirty="0"/>
+          </a:p>
+        </p:txBody>
+      </p:sp>
+      <p:sp>
+        <p:nvSpPr>
+          <p:cNvPr id="17" name="Text 14"/>
+          <p:cNvSpPr/>
+          <p:nvPr/>
+        </p:nvSpPr>
+        <p:spPr>
+          <a:xfrm>
+            <a:off x="5852160" y="2487168"/>
+            <a:ext cx="4242816" cy="1115568"/>
+          </a:xfrm>
+          <a:prstGeom prst="rect">
+            <a:avLst/>
+          </a:prstGeom>
+          <a:noFill/>
+          <a:ln/>
+        </p:spPr>
+        <p:txBody>
+          <a:bodyPr wrap="square" lIns="0" tIns="0" rIns="0" bIns="0" rtlCol="0" anchor="t"/>
+          <a:lstStyle/>
+          <a:p>
+            <a:pPr algn="l" indent="0" marL="0">
+              <a:buNone/>
+            </a:pPr>
+            <a:r>
+              <a:rPr lang="en-US" sz="1080" dirty="0">
+                <a:solidFill>
+                  <a:srgbClr val="243B53"/>
+                </a:solidFill>
+                <a:latin typeface="Aptos" pitchFamily="34" charset="0"/>
+                <a:ea typeface="Aptos" pitchFamily="34" charset="-122"/>
+                <a:cs typeface="Aptos" pitchFamily="34" charset="-120"/>
+              </a:rPr>
+              <a:t>Vínculos técnicos (FK) que definen la lógica del sistema.</a:t>
+            </a:r>
+            <a:endParaRPr lang="en-US" sz="1080" dirty="0"/>
+          </a:p>
+        </p:txBody>
+      </p:sp>
+      <p:sp>
+        <p:nvSpPr>
+          <p:cNvPr id="18" name="Shape 15"/>
+          <p:cNvSpPr/>
+          <p:nvPr/>
+        </p:nvSpPr>
+        <p:spPr>
+          <a:xfrm>
+            <a:off x="804672" y="3895344"/>
+            <a:ext cx="4590288" cy="1700784"/>
+          </a:xfrm>
+          <a:prstGeom prst="roundRect">
+            <a:avLst>
+              <a:gd name="adj" fmla="val 3226"/>
+            </a:avLst>
+          </a:prstGeom>
+          <a:solidFill>
+            <a:srgbClr val="FFFFFF"/>
+          </a:solidFill>
+          <a:ln w="12700">
+            <a:solidFill>
+              <a:srgbClr val="D8CFC4"/>
+            </a:solidFill>
+            <a:prstDash val="solid"/>
+          </a:ln>
+        </p:spPr>
+      </p:sp>
+      <p:sp>
+        <p:nvSpPr>
+          <p:cNvPr id="19" name="Shape 16"/>
+          <p:cNvSpPr/>
+          <p:nvPr/>
+        </p:nvSpPr>
+        <p:spPr>
+          <a:xfrm>
+            <a:off x="896112" y="4023360"/>
+            <a:ext cx="64008" cy="1444752"/>
+          </a:xfrm>
+          <a:prstGeom prst="rect">
+            <a:avLst/>
+          </a:prstGeom>
+          <a:solidFill>
+            <a:srgbClr val="E0BC5A"/>
+          </a:solidFill>
+          <a:ln w="12700">
+            <a:solidFill>
+              <a:srgbClr val="E0BC5A"/>
+            </a:solidFill>
+            <a:prstDash val="solid"/>
+          </a:ln>
+        </p:spPr>
+      </p:sp>
+      <p:sp>
+        <p:nvSpPr>
+          <p:cNvPr id="20" name="Text 17"/>
+          <p:cNvSpPr/>
+          <p:nvPr/>
+        </p:nvSpPr>
+        <p:spPr>
+          <a:xfrm>
+            <a:off x="1060704" y="4005072"/>
+            <a:ext cx="4242816" cy="310896"/>
+          </a:xfrm>
+          <a:prstGeom prst="rect">
+            <a:avLst/>
+          </a:prstGeom>
+          <a:noFill/>
+          <a:ln/>
+        </p:spPr>
+        <p:txBody>
+          <a:bodyPr wrap="square" lIns="0" tIns="0" rIns="0" bIns="0" rtlCol="0" anchor="ctr"/>
+          <a:lstStyle/>
+          <a:p>
+            <a:pPr indent="0" marL="0">
+              <a:buNone/>
+            </a:pPr>
+            <a:r>
+              <a:rPr lang="en-US" sz="1420" b="1" dirty="0">
+                <a:solidFill>
+                  <a:srgbClr val="102A43"/>
+                </a:solidFill>
+                <a:latin typeface="Aptos Display" pitchFamily="34" charset="0"/>
+                <a:ea typeface="Aptos Display" pitchFamily="34" charset="-122"/>
+                <a:cs typeface="Aptos Display" pitchFamily="34" charset="-120"/>
+              </a:rPr>
+              <a:t>Normalización</a:t>
+            </a:r>
+            <a:endParaRPr lang="en-US" sz="1420" dirty="0"/>
+          </a:p>
+        </p:txBody>
+      </p:sp>
+      <p:sp>
+        <p:nvSpPr>
+          <p:cNvPr id="21" name="Text 18"/>
+          <p:cNvSpPr/>
+          <p:nvPr/>
+        </p:nvSpPr>
+        <p:spPr>
+          <a:xfrm>
+            <a:off x="1060704" y="4352544"/>
+            <a:ext cx="4242816" cy="1115568"/>
+          </a:xfrm>
+          <a:prstGeom prst="rect">
+            <a:avLst/>
+          </a:prstGeom>
+          <a:noFill/>
+          <a:ln/>
+        </p:spPr>
+        <p:txBody>
+          <a:bodyPr wrap="square" lIns="0" tIns="0" rIns="0" bIns="0" rtlCol="0" anchor="t"/>
+          <a:lstStyle/>
+          <a:p>
+            <a:pPr algn="l" indent="0" marL="0">
+              <a:buNone/>
+            </a:pPr>
+            <a:r>
+              <a:rPr lang="en-US" sz="1080" dirty="0">
+                <a:solidFill>
+                  <a:srgbClr val="243B53"/>
+                </a:solidFill>
+                <a:latin typeface="Aptos" pitchFamily="34" charset="0"/>
+                <a:ea typeface="Aptos" pitchFamily="34" charset="-122"/>
+                <a:cs typeface="Aptos" pitchFamily="34" charset="-120"/>
+              </a:rPr>
+              <a:t>Diseño profesional para evitar redundancia y errores.</a:t>
+            </a:r>
+            <a:endParaRPr lang="en-US" sz="1080" dirty="0"/>
+          </a:p>
+        </p:txBody>
+      </p:sp>
+      <p:sp>
+        <p:nvSpPr>
+          <p:cNvPr id="22" name="Shape 19"/>
+          <p:cNvSpPr/>
+          <p:nvPr/>
+        </p:nvSpPr>
+        <p:spPr>
+          <a:xfrm>
+            <a:off x="5596128" y="3895344"/>
+            <a:ext cx="4590288" cy="1700784"/>
+          </a:xfrm>
+          <a:prstGeom prst="roundRect">
+            <a:avLst>
+              <a:gd name="adj" fmla="val 3226"/>
+            </a:avLst>
+          </a:prstGeom>
+          <a:solidFill>
+            <a:srgbClr val="FFFFFF"/>
+          </a:solidFill>
+          <a:ln w="12700">
+            <a:solidFill>
+              <a:srgbClr val="D8CFC4"/>
+            </a:solidFill>
+            <a:prstDash val="solid"/>
+          </a:ln>
+        </p:spPr>
+      </p:sp>
+      <p:sp>
+        <p:nvSpPr>
+          <p:cNvPr id="23" name="Shape 20"/>
+          <p:cNvSpPr/>
+          <p:nvPr/>
+        </p:nvSpPr>
+        <p:spPr>
+          <a:xfrm>
+            <a:off x="5687568" y="4023360"/>
+            <a:ext cx="64008" cy="1444752"/>
+          </a:xfrm>
+          <a:prstGeom prst="rect">
+            <a:avLst/>
+          </a:prstGeom>
+          <a:solidFill>
+            <a:srgbClr val="102A43"/>
+          </a:solidFill>
+          <a:ln w="12700">
+            <a:solidFill>
+              <a:srgbClr val="102A43"/>
+            </a:solidFill>
+            <a:prstDash val="solid"/>
+          </a:ln>
+        </p:spPr>
+      </p:sp>
+      <p:sp>
+        <p:nvSpPr>
+          <p:cNvPr id="24" name="Text 21"/>
+          <p:cNvSpPr/>
+          <p:nvPr/>
+        </p:nvSpPr>
+        <p:spPr>
+          <a:xfrm>
+            <a:off x="5852160" y="4005072"/>
+            <a:ext cx="4242816" cy="310896"/>
+          </a:xfrm>
+          <a:prstGeom prst="rect">
+            <a:avLst/>
+          </a:prstGeom>
+          <a:noFill/>
+          <a:ln/>
+        </p:spPr>
+        <p:txBody>
+          <a:bodyPr wrap="square" lIns="0" tIns="0" rIns="0" bIns="0" rtlCol="0" anchor="ctr"/>
+          <a:lstStyle/>
+          <a:p>
+            <a:pPr indent="0" marL="0">
+              <a:buNone/>
+            </a:pPr>
+            <a:r>
+              <a:rPr lang="en-US" sz="1420" b="1" dirty="0">
+                <a:solidFill>
+                  <a:srgbClr val="102A43"/>
+                </a:solidFill>
+                <a:latin typeface="Aptos Display" pitchFamily="34" charset="0"/>
+                <a:ea typeface="Aptos Display" pitchFamily="34" charset="-122"/>
+                <a:cs typeface="Aptos Display" pitchFamily="34" charset="-120"/>
+              </a:rPr>
+              <a:t>Persistencia</a:t>
+            </a:r>
+            <a:endParaRPr lang="en-US" sz="1420" dirty="0"/>
+          </a:p>
+        </p:txBody>
+      </p:sp>
+      <p:sp>
+        <p:nvSpPr>
+          <p:cNvPr id="25" name="Text 22"/>
+          <p:cNvSpPr/>
+          <p:nvPr/>
+        </p:nvSpPr>
+        <p:spPr>
+          <a:xfrm>
+            <a:off x="5852160" y="4352544"/>
+            <a:ext cx="4242816" cy="1115568"/>
+          </a:xfrm>
+          <a:prstGeom prst="rect">
+            <a:avLst/>
+          </a:prstGeom>
+          <a:noFill/>
+          <a:ln/>
+        </p:spPr>
+        <p:txBody>
+          <a:bodyPr wrap="square" lIns="0" tIns="0" rIns="0" bIns="0" rtlCol="0" anchor="t"/>
+          <a:lstStyle/>
+          <a:p>
+            <a:pPr algn="l" indent="0" marL="0">
+              <a:buNone/>
+            </a:pPr>
+            <a:r>
+              <a:rPr lang="en-US" sz="1080" dirty="0">
+                <a:solidFill>
+                  <a:srgbClr val="243B53"/>
+                </a:solidFill>
+                <a:latin typeface="Aptos" pitchFamily="34" charset="0"/>
+                <a:ea typeface="Aptos" pitchFamily="34" charset="-122"/>
+                <a:cs typeface="Aptos" pitchFamily="34" charset="-120"/>
+              </a:rPr>
+              <a:t>Implementación en la nube con Supabase y PostgreSQL.</a:t>
+            </a:r>
+            <a:endParaRPr lang="en-US" sz="1080" dirty="0"/>
+          </a:p>
+        </p:txBody>
+      </p:sp>
+    </p:spTree>
+  </p:cSld>
+  <p:clrMapOvr>
+    <a:masterClrMapping/>
+  </p:clrMapOvr>
+</p:sld>
+</file>
+
+<file path=ppt/slides/slide64.xml><?xml version="1.0" encoding="utf-8"?>
+<p:sld xmlns:a="http://schemas.openxmlformats.org/drawingml/2006/main" xmlns:r="http://schemas.openxmlformats.org/officeDocument/2006/relationships" xmlns:p="http://schemas.openxmlformats.org/presentationml/2006/main">
+  <p:cSld name="Slide 64">
+    <p:bg>
+      <p:bgPr>
+        <a:solidFill>
+          <a:srgbClr val="F8F3EC"/>
+        </a:solidFill>
+      </p:bgPr>
+    </p:bg>
+    <p:spTree>
+      <p:nvGrpSpPr>
+        <p:cNvPr id="1" name=""/>
+        <p:cNvGrpSpPr/>
+        <p:nvPr/>
+      </p:nvGrpSpPr>
+      <p:grpSpPr>
+        <a:xfrm>
+          <a:off x="0" y="0"/>
+          <a:ext cx="0" cy="0"/>
+          <a:chOff x="0" y="0"/>
+          <a:chExt cx="0" cy="0"/>
+        </a:xfrm>
+      </p:grpSpPr>
+      <p:sp>
+        <p:nvSpPr>
+          <p:cNvPr id="2" name="Shape 0"/>
+          <p:cNvSpPr/>
+          <p:nvPr/>
+        </p:nvSpPr>
+        <p:spPr>
+          <a:xfrm>
+            <a:off x="0" y="0"/>
+            <a:ext cx="12191695" cy="146304"/>
+          </a:xfrm>
+          <a:prstGeom prst="rect">
+            <a:avLst/>
+          </a:prstGeom>
+          <a:solidFill>
+            <a:srgbClr val="102A43"/>
+          </a:solidFill>
+          <a:ln w="12700">
+            <a:solidFill>
+              <a:srgbClr val="102A43"/>
+            </a:solidFill>
+            <a:prstDash val="solid"/>
+          </a:ln>
+        </p:spPr>
+      </p:sp>
+      <p:sp>
+        <p:nvSpPr>
+          <p:cNvPr id="3" name="Text 1"/>
+          <p:cNvSpPr/>
+          <p:nvPr/>
+        </p:nvSpPr>
+        <p:spPr>
+          <a:xfrm>
+            <a:off x="9829800" y="237744"/>
+            <a:ext cx="1737360" cy="640080"/>
+          </a:xfrm>
+          <a:prstGeom prst="rect">
+            <a:avLst/>
+          </a:prstGeom>
+          <a:noFill/>
+          <a:ln/>
+        </p:spPr>
+        <p:txBody>
+          <a:bodyPr wrap="square" lIns="0" tIns="0" rIns="0" bIns="0" rtlCol="0" anchor="ctr"/>
+          <a:lstStyle/>
+          <a:p>
+            <a:pPr algn="r" indent="0" marL="0">
+              <a:buNone/>
+            </a:pPr>
+            <a:r>
+              <a:rPr lang="en-US" sz="2800" b="1" dirty="0">
+                <a:solidFill>
+                  <a:srgbClr val="EADFD0"/>
+                </a:solidFill>
+                <a:latin typeface="Aptos Display" pitchFamily="34" charset="0"/>
+                <a:ea typeface="Aptos Display" pitchFamily="34" charset="-122"/>
+                <a:cs typeface="Aptos Display" pitchFamily="34" charset="-120"/>
+              </a:rPr>
+              <a:t>64</a:t>
+            </a:r>
+            <a:endParaRPr lang="en-US" sz="2800" dirty="0"/>
+          </a:p>
+        </p:txBody>
+      </p:sp>
+      <p:sp>
+        <p:nvSpPr>
+          <p:cNvPr id="4" name="Shape 2"/>
+          <p:cNvSpPr/>
+          <p:nvPr/>
+        </p:nvSpPr>
+        <p:spPr>
+          <a:xfrm>
+            <a:off x="658368" y="475488"/>
+            <a:ext cx="1993392" cy="310896"/>
+          </a:xfrm>
+          <a:prstGeom prst="roundRect">
+            <a:avLst>
+              <a:gd name="adj" fmla="val 14706"/>
+            </a:avLst>
+          </a:prstGeom>
+          <a:solidFill>
+            <a:srgbClr val="D62027"/>
+          </a:solidFill>
+          <a:ln w="12700">
+            <a:solidFill>
+              <a:srgbClr val="D62027"/>
+            </a:solidFill>
+            <a:prstDash val="solid"/>
+          </a:ln>
+        </p:spPr>
+      </p:sp>
+      <p:sp>
+        <p:nvSpPr>
+          <p:cNvPr id="5" name="Text 3"/>
+          <p:cNvSpPr/>
+          <p:nvPr/>
+        </p:nvSpPr>
+        <p:spPr>
+          <a:xfrm>
+            <a:off x="768096" y="512064"/>
+            <a:ext cx="1773936" cy="201168"/>
+          </a:xfrm>
+          <a:prstGeom prst="rect">
+            <a:avLst/>
+          </a:prstGeom>
+          <a:noFill/>
+          <a:ln/>
+        </p:spPr>
+        <p:txBody>
+          <a:bodyPr wrap="square" lIns="0" tIns="0" rIns="0" bIns="0" rtlCol="0" anchor="ctr"/>
+          <a:lstStyle/>
+          <a:p>
+            <a:pPr algn="ctr" indent="0" marL="0">
+              <a:buNone/>
+            </a:pPr>
+            <a:r>
+              <a:rPr lang="en-US" sz="950" b="1" dirty="0">
+                <a:solidFill>
+                  <a:srgbClr val="FFFFFF"/>
+                </a:solidFill>
+                <a:latin typeface="Aptos" pitchFamily="34" charset="0"/>
+                <a:ea typeface="Aptos" pitchFamily="34" charset="-122"/>
+                <a:cs typeface="Aptos" pitchFamily="34" charset="-120"/>
+              </a:rPr>
+              <a:t>Clase 14 · Cierre</a:t>
+            </a:r>
+            <a:endParaRPr lang="en-US" sz="950" dirty="0"/>
+          </a:p>
+        </p:txBody>
+      </p:sp>
+      <p:sp>
+        <p:nvSpPr>
+          <p:cNvPr id="6" name="Shape 4"/>
+          <p:cNvSpPr/>
+          <p:nvPr/>
+        </p:nvSpPr>
+        <p:spPr>
+          <a:xfrm>
+            <a:off x="10094976" y="859536"/>
+            <a:ext cx="987552" cy="749808"/>
+          </a:xfrm>
+          <a:prstGeom prst="ellipse">
+            <a:avLst/>
+          </a:prstGeom>
+          <a:solidFill>
+            <a:srgbClr val="EDE6DA"/>
+          </a:solidFill>
+          <a:ln w="12700">
+            <a:solidFill>
+              <a:srgbClr val="EDE6DA"/>
+            </a:solidFill>
+            <a:prstDash val="solid"/>
+          </a:ln>
+        </p:spPr>
+      </p:sp>
+      <p:pic>
+        <p:nvPicPr>
+          <p:cNvPr id="7" name="Image 0" descr="C:\Users\Diego Obando\dev\pro301-taller-de-aplicaciones-para-internet\.agent\skills\slides-aiep\assets\logo-aiep-mark.png">    </p:cNvPr>
+          <p:cNvPicPr>
+            <a:picLocks noChangeAspect="1"/>
+          </p:cNvPicPr>
+          <p:nvPr/>
+        </p:nvPicPr>
+        <p:blipFill>
+          <a:blip r:embed="rId1"/>
+          <a:stretch>
+            <a:fillRect/>
+          </a:stretch>
+        </p:blipFill>
+        <p:spPr>
+          <a:xfrm>
+            <a:off x="10342310" y="1060704"/>
+            <a:ext cx="492884" cy="310896"/>
+          </a:xfrm>
+          <a:prstGeom prst="rect">
+            <a:avLst/>
+          </a:prstGeom>
+        </p:spPr>
+      </p:pic>
+      <p:sp>
+        <p:nvSpPr>
+          <p:cNvPr id="8" name="Text 5"/>
+          <p:cNvSpPr/>
+          <p:nvPr/>
+        </p:nvSpPr>
+        <p:spPr>
+          <a:xfrm>
+            <a:off x="658368" y="859536"/>
+            <a:ext cx="8138160" cy="603504"/>
+          </a:xfrm>
+          <a:prstGeom prst="rect">
+            <a:avLst/>
+          </a:prstGeom>
+          <a:noFill/>
+          <a:ln/>
+        </p:spPr>
+        <p:txBody>
+          <a:bodyPr wrap="square" lIns="0" tIns="0" rIns="0" bIns="0" rtlCol="0" anchor="ctr"/>
+          <a:lstStyle/>
+          <a:p>
+            <a:pPr indent="0" marL="0">
+              <a:buNone/>
+            </a:pPr>
+            <a:r>
+              <a:rPr lang="en-US" sz="2400" b="1" dirty="0">
+                <a:solidFill>
+                  <a:srgbClr val="102A43"/>
+                </a:solidFill>
+                <a:latin typeface="Aptos Display" pitchFamily="34" charset="0"/>
+                <a:ea typeface="Aptos Display" pitchFamily="34" charset="-122"/>
+                <a:cs typeface="Aptos Display" pitchFamily="34" charset="-120"/>
+              </a:rPr>
+              <a:t>Desafío Mental de Integración</a:t>
+            </a:r>
+            <a:endParaRPr lang="en-US" sz="2400" dirty="0"/>
+          </a:p>
+        </p:txBody>
+      </p:sp>
+      <p:sp>
+        <p:nvSpPr>
+          <p:cNvPr id="9" name="Text 6"/>
+          <p:cNvSpPr/>
+          <p:nvPr/>
+        </p:nvSpPr>
+        <p:spPr>
+          <a:xfrm>
+            <a:off x="676656" y="1536192"/>
+            <a:ext cx="8275320" cy="201168"/>
+          </a:xfrm>
+          <a:prstGeom prst="rect">
+            <a:avLst/>
+          </a:prstGeom>
+          <a:noFill/>
+          <a:ln/>
+        </p:spPr>
+        <p:txBody>
+          <a:bodyPr wrap="square" lIns="0" tIns="0" rIns="0" bIns="0" rtlCol="0" anchor="ctr"/>
+          <a:lstStyle/>
+          <a:p>
+            <a:pPr indent="0" marL="0">
+              <a:buNone/>
+            </a:pPr>
+            <a:r>
+              <a:rPr lang="en-US" sz="1060" dirty="0">
+                <a:solidFill>
+                  <a:srgbClr val="52606D"/>
+                </a:solidFill>
+                <a:latin typeface="Aptos" pitchFamily="34" charset="0"/>
+                <a:ea typeface="Aptos" pitchFamily="34" charset="-122"/>
+                <a:cs typeface="Aptos" pitchFamily="34" charset="-120"/>
+              </a:rPr>
+              <a:t>Aplicando lo aprendido</a:t>
+            </a:r>
+            <a:endParaRPr lang="en-US" sz="1060" dirty="0"/>
+          </a:p>
+        </p:txBody>
+      </p:sp>
+      <p:sp>
+        <p:nvSpPr>
+          <p:cNvPr id="10" name="Shape 7"/>
+          <p:cNvSpPr/>
+          <p:nvPr/>
+        </p:nvSpPr>
+        <p:spPr>
+          <a:xfrm>
+            <a:off x="804672" y="2029968"/>
+            <a:ext cx="9381744" cy="749808"/>
+          </a:xfrm>
+          <a:prstGeom prst="roundRect">
+            <a:avLst>
+              <a:gd name="adj" fmla="val 4878"/>
+            </a:avLst>
+          </a:prstGeom>
+          <a:solidFill>
+            <a:srgbClr val="EDE6DA"/>
+          </a:solidFill>
+          <a:ln w="12700">
+            <a:solidFill>
+              <a:srgbClr val="EDE6DA"/>
+            </a:solidFill>
+            <a:prstDash val="solid"/>
+          </a:ln>
+        </p:spPr>
+      </p:sp>
+      <p:sp>
+        <p:nvSpPr>
+          <p:cNvPr id="11" name="Text 8"/>
+          <p:cNvSpPr/>
+          <p:nvPr/>
+        </p:nvSpPr>
+        <p:spPr>
+          <a:xfrm>
+            <a:off x="1005840" y="2194560"/>
+            <a:ext cx="8979408" cy="420624"/>
+          </a:xfrm>
+          <a:prstGeom prst="rect">
+            <a:avLst/>
+          </a:prstGeom>
+          <a:noFill/>
+          <a:ln/>
+        </p:spPr>
+        <p:txBody>
+          <a:bodyPr wrap="square" lIns="0" tIns="0" rIns="0" bIns="0" rtlCol="0" anchor="ctr"/>
+          <a:lstStyle/>
+          <a:p>
+            <a:pPr algn="ctr" indent="0" marL="0">
+              <a:buNone/>
+            </a:pPr>
+            <a:r>
+              <a:rPr lang="en-US" sz="1800" b="1" dirty="0">
+                <a:solidFill>
+                  <a:srgbClr val="102A43"/>
+                </a:solidFill>
+                <a:latin typeface="Aptos Display" pitchFamily="34" charset="0"/>
+                <a:ea typeface="Aptos Display" pitchFamily="34" charset="-122"/>
+                <a:cs typeface="Aptos Display" pitchFamily="34" charset="-120"/>
+              </a:rPr>
+              <a:t>¿Cómo modelarías una aplicación de Delivery tipo UberEats?</a:t>
+            </a:r>
+            <a:endParaRPr lang="en-US" sz="1800" dirty="0"/>
+          </a:p>
+        </p:txBody>
+      </p:sp>
+      <p:sp>
+        <p:nvSpPr>
+          <p:cNvPr id="12" name="Shape 9"/>
+          <p:cNvSpPr/>
+          <p:nvPr/>
+        </p:nvSpPr>
+        <p:spPr>
+          <a:xfrm>
+            <a:off x="804672" y="3127248"/>
+            <a:ext cx="2194560" cy="2560320"/>
+          </a:xfrm>
+          <a:prstGeom prst="roundRect">
+            <a:avLst>
+              <a:gd name="adj" fmla="val 1250"/>
+            </a:avLst>
+          </a:prstGeom>
+          <a:solidFill>
+            <a:srgbClr val="FFFFFF"/>
+          </a:solidFill>
+          <a:ln w="12700">
+            <a:solidFill>
+              <a:srgbClr val="D8CFC4"/>
+            </a:solidFill>
+            <a:prstDash val="solid"/>
+          </a:ln>
+        </p:spPr>
+      </p:sp>
+      <p:sp>
+        <p:nvSpPr>
+          <p:cNvPr id="13" name="Shape 10"/>
+          <p:cNvSpPr/>
+          <p:nvPr/>
+        </p:nvSpPr>
+        <p:spPr>
+          <a:xfrm>
+            <a:off x="877824" y="3236976"/>
+            <a:ext cx="100584" cy="2340864"/>
+          </a:xfrm>
+          <a:prstGeom prst="rect">
+            <a:avLst/>
+          </a:prstGeom>
+          <a:solidFill>
+            <a:srgbClr val="D62027"/>
+          </a:solidFill>
+          <a:ln w="12700">
+            <a:solidFill>
+              <a:srgbClr val="D62027"/>
+            </a:solidFill>
+            <a:prstDash val="solid"/>
+          </a:ln>
+        </p:spPr>
+      </p:sp>
+      <p:sp>
+        <p:nvSpPr>
+          <p:cNvPr id="14" name="Text 11"/>
+          <p:cNvSpPr/>
+          <p:nvPr/>
+        </p:nvSpPr>
+        <p:spPr>
+          <a:xfrm>
+            <a:off x="1060704" y="3255264"/>
+            <a:ext cx="1865376" cy="219456"/>
+          </a:xfrm>
+          <a:prstGeom prst="rect">
+            <a:avLst/>
+          </a:prstGeom>
+          <a:noFill/>
+          <a:ln/>
+        </p:spPr>
+        <p:txBody>
+          <a:bodyPr wrap="square" lIns="0" tIns="0" rIns="0" bIns="0" rtlCol="0" anchor="ctr"/>
+          <a:lstStyle/>
+          <a:p>
+            <a:pPr indent="0" marL="0">
+              <a:buNone/>
+            </a:pPr>
+            <a:r>
+              <a:rPr lang="en-US" sz="1100" b="1" dirty="0">
+                <a:solidFill>
+                  <a:srgbClr val="102A43"/>
+                </a:solidFill>
+                <a:latin typeface="Aptos Display" pitchFamily="34" charset="0"/>
+                <a:ea typeface="Aptos Display" pitchFamily="34" charset="-122"/>
+                <a:cs typeface="Aptos Display" pitchFamily="34" charset="-120"/>
+              </a:rPr>
+              <a:t>1. Entidades</a:t>
+            </a:r>
+            <a:endParaRPr lang="en-US" sz="1100" dirty="0"/>
+          </a:p>
+        </p:txBody>
+      </p:sp>
+      <p:sp>
+        <p:nvSpPr>
+          <p:cNvPr id="15" name="Text 12"/>
+          <p:cNvSpPr/>
+          <p:nvPr/>
+        </p:nvSpPr>
+        <p:spPr>
+          <a:xfrm>
+            <a:off x="1060704" y="3529584"/>
+            <a:ext cx="1865376" cy="2066544"/>
+          </a:xfrm>
+          <a:prstGeom prst="rect">
+            <a:avLst/>
+          </a:prstGeom>
+          <a:noFill/>
+          <a:ln/>
+        </p:spPr>
+        <p:txBody>
+          <a:bodyPr wrap="square" lIns="0" tIns="0" rIns="0" bIns="0" rtlCol="0" anchor="t"/>
+          <a:lstStyle/>
+          <a:p>
+            <a:pPr indent="0" marL="0">
+              <a:buNone/>
+            </a:pPr>
+            <a:r>
+              <a:rPr lang="en-US" sz="950" dirty="0">
+                <a:solidFill>
+                  <a:srgbClr val="243B53"/>
+                </a:solidFill>
+                <a:latin typeface="Aptos" pitchFamily="34" charset="0"/>
+                <a:ea typeface="Aptos" pitchFamily="34" charset="-122"/>
+                <a:cs typeface="Aptos" pitchFamily="34" charset="-120"/>
+              </a:rPr>
+              <a:t>Restaurante, Plato, Pedido, Cliente, Rider.</a:t>
+            </a:r>
+            <a:endParaRPr lang="en-US" sz="950" dirty="0"/>
+          </a:p>
+        </p:txBody>
+      </p:sp>
+      <p:sp>
+        <p:nvSpPr>
+          <p:cNvPr id="16" name="Shape 13"/>
+          <p:cNvSpPr/>
+          <p:nvPr/>
+        </p:nvSpPr>
+        <p:spPr>
+          <a:xfrm>
+            <a:off x="3182112" y="3127248"/>
+            <a:ext cx="2194560" cy="2560320"/>
+          </a:xfrm>
+          <a:prstGeom prst="roundRect">
+            <a:avLst>
+              <a:gd name="adj" fmla="val 1250"/>
+            </a:avLst>
+          </a:prstGeom>
+          <a:solidFill>
+            <a:srgbClr val="FFFFFF"/>
+          </a:solidFill>
+          <a:ln w="12700">
+            <a:solidFill>
+              <a:srgbClr val="D8CFC4"/>
+            </a:solidFill>
+            <a:prstDash val="solid"/>
+          </a:ln>
+        </p:spPr>
+      </p:sp>
+      <p:sp>
+        <p:nvSpPr>
+          <p:cNvPr id="17" name="Shape 14"/>
+          <p:cNvSpPr/>
+          <p:nvPr/>
+        </p:nvSpPr>
+        <p:spPr>
+          <a:xfrm>
+            <a:off x="3255264" y="3236976"/>
+            <a:ext cx="100584" cy="2340864"/>
+          </a:xfrm>
+          <a:prstGeom prst="rect">
+            <a:avLst/>
+          </a:prstGeom>
+          <a:solidFill>
+            <a:srgbClr val="D62027"/>
+          </a:solidFill>
+          <a:ln w="12700">
+            <a:solidFill>
+              <a:srgbClr val="D62027"/>
+            </a:solidFill>
+            <a:prstDash val="solid"/>
+          </a:ln>
+        </p:spPr>
+      </p:sp>
+      <p:sp>
+        <p:nvSpPr>
+          <p:cNvPr id="18" name="Text 15"/>
+          <p:cNvSpPr/>
+          <p:nvPr/>
+        </p:nvSpPr>
+        <p:spPr>
+          <a:xfrm>
+            <a:off x="3438144" y="3255264"/>
+            <a:ext cx="1865376" cy="219456"/>
+          </a:xfrm>
+          <a:prstGeom prst="rect">
+            <a:avLst/>
+          </a:prstGeom>
+          <a:noFill/>
+          <a:ln/>
+        </p:spPr>
+        <p:txBody>
+          <a:bodyPr wrap="square" lIns="0" tIns="0" rIns="0" bIns="0" rtlCol="0" anchor="ctr"/>
+          <a:lstStyle/>
+          <a:p>
+            <a:pPr indent="0" marL="0">
+              <a:buNone/>
+            </a:pPr>
+            <a:r>
+              <a:rPr lang="en-US" sz="1100" b="1" dirty="0">
+                <a:solidFill>
+                  <a:srgbClr val="102A43"/>
+                </a:solidFill>
+                <a:latin typeface="Aptos Display" pitchFamily="34" charset="0"/>
+                <a:ea typeface="Aptos Display" pitchFamily="34" charset="-122"/>
+                <a:cs typeface="Aptos Display" pitchFamily="34" charset="-120"/>
+              </a:rPr>
+              <a:t>2. Relaciones</a:t>
+            </a:r>
+            <a:endParaRPr lang="en-US" sz="1100" dirty="0"/>
+          </a:p>
+        </p:txBody>
+      </p:sp>
+      <p:sp>
+        <p:nvSpPr>
+          <p:cNvPr id="19" name="Text 16"/>
+          <p:cNvSpPr/>
+          <p:nvPr/>
+        </p:nvSpPr>
+        <p:spPr>
+          <a:xfrm>
+            <a:off x="3438144" y="3529584"/>
+            <a:ext cx="1865376" cy="2066544"/>
+          </a:xfrm>
+          <a:prstGeom prst="rect">
+            <a:avLst/>
+          </a:prstGeom>
+          <a:noFill/>
+          <a:ln/>
+        </p:spPr>
+        <p:txBody>
+          <a:bodyPr wrap="square" lIns="0" tIns="0" rIns="0" bIns="0" rtlCol="0" anchor="t"/>
+          <a:lstStyle/>
+          <a:p>
+            <a:pPr indent="0" marL="0">
+              <a:buNone/>
+            </a:pPr>
+            <a:r>
+              <a:rPr lang="en-US" sz="950" dirty="0">
+                <a:solidFill>
+                  <a:srgbClr val="243B53"/>
+                </a:solidFill>
+                <a:latin typeface="Aptos" pitchFamily="34" charset="0"/>
+                <a:ea typeface="Aptos" pitchFamily="34" charset="-122"/>
+                <a:cs typeface="Aptos" pitchFamily="34" charset="-120"/>
+              </a:rPr>
+              <a:t>Un Restaurante tiene muchos Platos (1:N).</a:t>
+            </a:r>
+            <a:endParaRPr lang="en-US" sz="950" dirty="0"/>
+          </a:p>
+        </p:txBody>
+      </p:sp>
+      <p:sp>
+        <p:nvSpPr>
+          <p:cNvPr id="20" name="Shape 17"/>
+          <p:cNvSpPr/>
+          <p:nvPr/>
+        </p:nvSpPr>
+        <p:spPr>
+          <a:xfrm>
+            <a:off x="5559552" y="3127248"/>
+            <a:ext cx="2194560" cy="2560320"/>
+          </a:xfrm>
+          <a:prstGeom prst="roundRect">
+            <a:avLst>
+              <a:gd name="adj" fmla="val 1250"/>
+            </a:avLst>
+          </a:prstGeom>
+          <a:solidFill>
+            <a:srgbClr val="FFFFFF"/>
+          </a:solidFill>
+          <a:ln w="12700">
+            <a:solidFill>
+              <a:srgbClr val="D8CFC4"/>
+            </a:solidFill>
+            <a:prstDash val="solid"/>
+          </a:ln>
+        </p:spPr>
+      </p:sp>
+      <p:sp>
+        <p:nvSpPr>
+          <p:cNvPr id="21" name="Shape 18"/>
+          <p:cNvSpPr/>
+          <p:nvPr/>
+        </p:nvSpPr>
+        <p:spPr>
+          <a:xfrm>
+            <a:off x="5632704" y="3236976"/>
+            <a:ext cx="100584" cy="2340864"/>
+          </a:xfrm>
+          <a:prstGeom prst="rect">
+            <a:avLst/>
+          </a:prstGeom>
+          <a:solidFill>
+            <a:srgbClr val="D62027"/>
+          </a:solidFill>
+          <a:ln w="12700">
+            <a:solidFill>
+              <a:srgbClr val="D62027"/>
+            </a:solidFill>
+            <a:prstDash val="solid"/>
+          </a:ln>
+        </p:spPr>
+      </p:sp>
+      <p:sp>
+        <p:nvSpPr>
+          <p:cNvPr id="22" name="Text 19"/>
+          <p:cNvSpPr/>
+          <p:nvPr/>
+        </p:nvSpPr>
+        <p:spPr>
+          <a:xfrm>
+            <a:off x="5815584" y="3255264"/>
+            <a:ext cx="1865376" cy="219456"/>
+          </a:xfrm>
+          <a:prstGeom prst="rect">
+            <a:avLst/>
+          </a:prstGeom>
+          <a:noFill/>
+          <a:ln/>
+        </p:spPr>
+        <p:txBody>
+          <a:bodyPr wrap="square" lIns="0" tIns="0" rIns="0" bIns="0" rtlCol="0" anchor="ctr"/>
+          <a:lstStyle/>
+          <a:p>
+            <a:pPr indent="0" marL="0">
+              <a:buNone/>
+            </a:pPr>
+            <a:r>
+              <a:rPr lang="en-US" sz="1100" b="1" dirty="0">
+                <a:solidFill>
+                  <a:srgbClr val="102A43"/>
+                </a:solidFill>
+                <a:latin typeface="Aptos Display" pitchFamily="34" charset="0"/>
+                <a:ea typeface="Aptos Display" pitchFamily="34" charset="-122"/>
+                <a:cs typeface="Aptos Display" pitchFamily="34" charset="-120"/>
+              </a:rPr>
+              <a:t>3. Tabla Pivot</a:t>
+            </a:r>
+            <a:endParaRPr lang="en-US" sz="1100" dirty="0"/>
+          </a:p>
+        </p:txBody>
+      </p:sp>
+      <p:sp>
+        <p:nvSpPr>
+          <p:cNvPr id="23" name="Text 20"/>
+          <p:cNvSpPr/>
+          <p:nvPr/>
+        </p:nvSpPr>
+        <p:spPr>
+          <a:xfrm>
+            <a:off x="5815584" y="3529584"/>
+            <a:ext cx="1865376" cy="2066544"/>
+          </a:xfrm>
+          <a:prstGeom prst="rect">
+            <a:avLst/>
+          </a:prstGeom>
+          <a:noFill/>
+          <a:ln/>
+        </p:spPr>
+        <p:txBody>
+          <a:bodyPr wrap="square" lIns="0" tIns="0" rIns="0" bIns="0" rtlCol="0" anchor="t"/>
+          <a:lstStyle/>
+          <a:p>
+            <a:pPr indent="0" marL="0">
+              <a:buNone/>
+            </a:pPr>
+            <a:r>
+              <a:rPr lang="en-US" sz="950" dirty="0">
+                <a:solidFill>
+                  <a:srgbClr val="243B53"/>
+                </a:solidFill>
+                <a:latin typeface="Aptos" pitchFamily="34" charset="0"/>
+                <a:ea typeface="Aptos" pitchFamily="34" charset="-122"/>
+                <a:cs typeface="Aptos" pitchFamily="34" charset="-120"/>
+              </a:rPr>
+              <a:t>¿Cómo relacionas Pedidos con muchos Platos?</a:t>
+            </a:r>
+            <a:endParaRPr lang="en-US" sz="950" dirty="0"/>
+          </a:p>
+        </p:txBody>
+      </p:sp>
+      <p:sp>
+        <p:nvSpPr>
+          <p:cNvPr id="24" name="Shape 21"/>
+          <p:cNvSpPr/>
+          <p:nvPr/>
+        </p:nvSpPr>
+        <p:spPr>
+          <a:xfrm>
+            <a:off x="7936992" y="3127248"/>
+            <a:ext cx="2194560" cy="2560320"/>
+          </a:xfrm>
+          <a:prstGeom prst="roundRect">
+            <a:avLst>
+              <a:gd name="adj" fmla="val 1250"/>
+            </a:avLst>
+          </a:prstGeom>
+          <a:solidFill>
+            <a:srgbClr val="FFFFFF"/>
+          </a:solidFill>
+          <a:ln w="12700">
+            <a:solidFill>
+              <a:srgbClr val="D8CFC4"/>
+            </a:solidFill>
+            <a:prstDash val="solid"/>
+          </a:ln>
+        </p:spPr>
+      </p:sp>
+      <p:sp>
+        <p:nvSpPr>
+          <p:cNvPr id="25" name="Shape 22"/>
+          <p:cNvSpPr/>
+          <p:nvPr/>
+        </p:nvSpPr>
+        <p:spPr>
+          <a:xfrm>
+            <a:off x="8010144" y="3236976"/>
+            <a:ext cx="100584" cy="2340864"/>
+          </a:xfrm>
+          <a:prstGeom prst="rect">
+            <a:avLst/>
+          </a:prstGeom>
+          <a:solidFill>
+            <a:srgbClr val="D62027"/>
+          </a:solidFill>
+          <a:ln w="12700">
+            <a:solidFill>
+              <a:srgbClr val="D62027"/>
+            </a:solidFill>
+            <a:prstDash val="solid"/>
+          </a:ln>
+        </p:spPr>
+      </p:sp>
+      <p:sp>
+        <p:nvSpPr>
+          <p:cNvPr id="26" name="Text 23"/>
+          <p:cNvSpPr/>
+          <p:nvPr/>
+        </p:nvSpPr>
+        <p:spPr>
+          <a:xfrm>
+            <a:off x="8193024" y="3255264"/>
+            <a:ext cx="1865376" cy="219456"/>
+          </a:xfrm>
+          <a:prstGeom prst="rect">
+            <a:avLst/>
+          </a:prstGeom>
+          <a:noFill/>
+          <a:ln/>
+        </p:spPr>
+        <p:txBody>
+          <a:bodyPr wrap="square" lIns="0" tIns="0" rIns="0" bIns="0" rtlCol="0" anchor="ctr"/>
+          <a:lstStyle/>
+          <a:p>
+            <a:pPr indent="0" marL="0">
+              <a:buNone/>
+            </a:pPr>
+            <a:r>
+              <a:rPr lang="en-US" sz="1100" b="1" dirty="0">
+                <a:solidFill>
+                  <a:srgbClr val="102A43"/>
+                </a:solidFill>
+                <a:latin typeface="Aptos Display" pitchFamily="34" charset="0"/>
+                <a:ea typeface="Aptos Display" pitchFamily="34" charset="-122"/>
+                <a:cs typeface="Aptos Display" pitchFamily="34" charset="-120"/>
+              </a:rPr>
+              <a:t>4. Tipos Datos</a:t>
+            </a:r>
+            <a:endParaRPr lang="en-US" sz="1100" dirty="0"/>
+          </a:p>
+        </p:txBody>
+      </p:sp>
+      <p:sp>
+        <p:nvSpPr>
+          <p:cNvPr id="27" name="Text 24"/>
+          <p:cNvSpPr/>
+          <p:nvPr/>
+        </p:nvSpPr>
+        <p:spPr>
+          <a:xfrm>
+            <a:off x="8193024" y="3529584"/>
+            <a:ext cx="1865376" cy="2066544"/>
+          </a:xfrm>
+          <a:prstGeom prst="rect">
+            <a:avLst/>
+          </a:prstGeom>
+          <a:noFill/>
+          <a:ln/>
+        </p:spPr>
+        <p:txBody>
+          <a:bodyPr wrap="square" lIns="0" tIns="0" rIns="0" bIns="0" rtlCol="0" anchor="t"/>
+          <a:lstStyle/>
+          <a:p>
+            <a:pPr indent="0" marL="0">
+              <a:buNone/>
+            </a:pPr>
+            <a:r>
+              <a:rPr lang="en-US" sz="950" dirty="0">
+                <a:solidFill>
+                  <a:srgbClr val="243B53"/>
+                </a:solidFill>
+                <a:latin typeface="Aptos" pitchFamily="34" charset="0"/>
+                <a:ea typeface="Aptos" pitchFamily="34" charset="-122"/>
+                <a:cs typeface="Aptos" pitchFamily="34" charset="-120"/>
+              </a:rPr>
+              <a:t>¿UUID para IDs? ¿Numeric para el total?</a:t>
+            </a:r>
+            <a:endParaRPr lang="en-US" sz="950" dirty="0"/>
+          </a:p>
+        </p:txBody>
+      </p:sp>
+    </p:spTree>
+  </p:cSld>
+  <p:clrMapOvr>
+    <a:masterClrMapping/>
+  </p:clrMapOvr>
+</p:sld>
+</file>
+
+<file path=ppt/slides/slide65.xml><?xml version="1.0" encoding="utf-8"?>
+<p:sld xmlns:a="http://schemas.openxmlformats.org/drawingml/2006/main" xmlns:r="http://schemas.openxmlformats.org/officeDocument/2006/relationships" xmlns:p="http://schemas.openxmlformats.org/presentationml/2006/main">
+  <p:cSld name="Slide 65">
+    <p:bg>
+      <p:bgPr>
+        <a:solidFill>
+          <a:srgbClr val="F2E7D9"/>
+        </a:solidFill>
+      </p:bgPr>
+    </p:bg>
+    <p:spTree>
+      <p:nvGrpSpPr>
+        <p:cNvPr id="1" name=""/>
+        <p:cNvGrpSpPr/>
+        <p:nvPr/>
+      </p:nvGrpSpPr>
+      <p:grpSpPr>
+        <a:xfrm>
+          <a:off x="0" y="0"/>
+          <a:ext cx="0" cy="0"/>
+          <a:chOff x="0" y="0"/>
+          <a:chExt cx="0" cy="0"/>
+        </a:xfrm>
+      </p:grpSpPr>
+      <p:sp>
+        <p:nvSpPr>
+          <p:cNvPr id="2" name="Shape 0"/>
+          <p:cNvSpPr/>
+          <p:nvPr/>
+        </p:nvSpPr>
+        <p:spPr>
+          <a:xfrm>
+            <a:off x="8796528" y="256032"/>
+            <a:ext cx="621792" cy="621792"/>
+          </a:xfrm>
+          <a:prstGeom prst="ellipse">
+            <a:avLst/>
+          </a:prstGeom>
+          <a:solidFill>
+            <a:srgbClr val="EDE6DA"/>
+          </a:solidFill>
+          <a:ln w="12700">
+            <a:solidFill>
+              <a:srgbClr val="EDE6DA"/>
+            </a:solidFill>
+            <a:prstDash val="solid"/>
+          </a:ln>
+        </p:spPr>
+      </p:sp>
+      <p:pic>
+        <p:nvPicPr>
+          <p:cNvPr id="3" name="Image 0" descr="C:\Users\Diego Obando\dev\pro301-taller-de-aplicaciones-para-internet\.agent\skills\slides-aiep\assets\logo-aiep-mark.png">    </p:cNvPr>
+          <p:cNvPicPr>
+            <a:picLocks noChangeAspect="1"/>
+          </p:cNvPicPr>
+          <p:nvPr/>
+        </p:nvPicPr>
+        <p:blipFill>
+          <a:blip r:embed="rId1"/>
+          <a:stretch>
+            <a:fillRect/>
+          </a:stretch>
+        </p:blipFill>
+        <p:spPr>
+          <a:xfrm>
+            <a:off x="10342310" y="1060704"/>
+            <a:ext cx="492884" cy="310896"/>
+          </a:xfrm>
+          <a:prstGeom prst="rect">
+            <a:avLst/>
+          </a:prstGeom>
+        </p:spPr>
+      </p:pic>
+      <p:sp>
+        <p:nvSpPr>
+          <p:cNvPr id="4" name="Shape 1"/>
+          <p:cNvSpPr/>
+          <p:nvPr/>
+        </p:nvSpPr>
+        <p:spPr>
+          <a:xfrm>
+            <a:off x="804672" y="402336"/>
+            <a:ext cx="2560320" cy="274320"/>
+          </a:xfrm>
+          <a:prstGeom prst="roundRect">
+            <a:avLst>
+              <a:gd name="adj" fmla="val 16667"/>
+            </a:avLst>
+          </a:prstGeom>
+          <a:solidFill>
+            <a:srgbClr val="D62027"/>
+          </a:solidFill>
+          <a:ln w="12700">
+            <a:solidFill>
+              <a:srgbClr val="D62027"/>
+            </a:solidFill>
+            <a:prstDash val="solid"/>
+          </a:ln>
+        </p:spPr>
+      </p:sp>
+      <p:sp>
+        <p:nvSpPr>
+          <p:cNvPr id="5" name="Text 2"/>
+          <p:cNvSpPr/>
+          <p:nvPr/>
+        </p:nvSpPr>
+        <p:spPr>
+          <a:xfrm>
+            <a:off x="914400" y="438912"/>
+            <a:ext cx="2340864" cy="201168"/>
+          </a:xfrm>
+          <a:prstGeom prst="rect">
+            <a:avLst/>
+          </a:prstGeom>
+          <a:noFill/>
+          <a:ln/>
+        </p:spPr>
+        <p:txBody>
+          <a:bodyPr wrap="square" lIns="0" tIns="0" rIns="0" bIns="0" rtlCol="0" anchor="ctr"/>
+          <a:lstStyle/>
+          <a:p>
+            <a:pPr algn="ctr" indent="0" marL="0">
+              <a:buNone/>
+            </a:pPr>
+            <a:r>
+              <a:rPr lang="en-US" sz="1000" b="1" dirty="0">
+                <a:solidFill>
+                  <a:srgbClr val="FFFFFF"/>
+                </a:solidFill>
+                <a:latin typeface="Aptos" pitchFamily="34" charset="0"/>
+                <a:ea typeface="Aptos" pitchFamily="34" charset="-122"/>
+                <a:cs typeface="Aptos" pitchFamily="34" charset="-120"/>
+              </a:rPr>
+              <a:t>PREGUNTAS DE SALIDA</a:t>
+            </a:r>
+            <a:endParaRPr lang="en-US" sz="1000" dirty="0"/>
+          </a:p>
+        </p:txBody>
+      </p:sp>
+      <p:sp>
+        <p:nvSpPr>
+          <p:cNvPr id="6" name="Text 3"/>
+          <p:cNvSpPr/>
+          <p:nvPr/>
+        </p:nvSpPr>
+        <p:spPr>
+          <a:xfrm>
+            <a:off x="804672" y="1060704"/>
+            <a:ext cx="530352" cy="621792"/>
+          </a:xfrm>
+          <a:prstGeom prst="rect">
+            <a:avLst/>
+          </a:prstGeom>
+          <a:noFill/>
+          <a:ln/>
+        </p:spPr>
+        <p:txBody>
+          <a:bodyPr wrap="square" lIns="0" tIns="0" rIns="0" bIns="0" rtlCol="0" anchor="ctr"/>
+          <a:lstStyle/>
+          <a:p>
+            <a:pPr indent="0" marL="0">
+              <a:buNone/>
+            </a:pPr>
+            <a:r>
+              <a:rPr lang="en-US" sz="3800" b="1" dirty="0">
+                <a:solidFill>
+                  <a:srgbClr val="D8CFC4"/>
+                </a:solidFill>
+                <a:latin typeface="Aptos Display" pitchFamily="34" charset="0"/>
+                <a:ea typeface="Aptos Display" pitchFamily="34" charset="-122"/>
+                <a:cs typeface="Aptos Display" pitchFamily="34" charset="-120"/>
+              </a:rPr>
+              <a:t>A</a:t>
+            </a:r>
+            <a:endParaRPr lang="en-US" sz="3800" dirty="0"/>
+          </a:p>
+        </p:txBody>
+      </p:sp>
+      <p:sp>
+        <p:nvSpPr>
+          <p:cNvPr id="7" name="Text 4"/>
+          <p:cNvSpPr/>
+          <p:nvPr/>
+        </p:nvSpPr>
+        <p:spPr>
+          <a:xfrm>
+            <a:off x="1463040" y="1024128"/>
+            <a:ext cx="7973568" cy="1426464"/>
+          </a:xfrm>
+          <a:prstGeom prst="rect">
+            <a:avLst/>
+          </a:prstGeom>
+          <a:noFill/>
+          <a:ln/>
+        </p:spPr>
+        <p:txBody>
+          <a:bodyPr wrap="square" lIns="0" tIns="0" rIns="0" bIns="0" rtlCol="0" anchor="ctr"/>
+          <a:lstStyle/>
+          <a:p>
+            <a:pPr indent="0" marL="0">
+              <a:buNone/>
+            </a:pPr>
+            <a:r>
+              <a:rPr lang="en-US" sz="1560" dirty="0">
+                <a:solidFill>
+                  <a:srgbClr val="102A43"/>
+                </a:solidFill>
+                <a:latin typeface="Aptos" pitchFamily="34" charset="0"/>
+                <a:ea typeface="Aptos" pitchFamily="34" charset="-122"/>
+                <a:cs typeface="Aptos" pitchFamily="34" charset="-120"/>
+              </a:rPr>
+              <a:t>¿Qué pasaría en una base de datos de millones de usuarios si no usáramos Primary Keys?</a:t>
+            </a:r>
+            <a:endParaRPr lang="en-US" sz="1560" dirty="0"/>
+          </a:p>
+        </p:txBody>
+      </p:sp>
+      <p:sp>
+        <p:nvSpPr>
+          <p:cNvPr id="8" name="Shape 5"/>
+          <p:cNvSpPr/>
+          <p:nvPr/>
+        </p:nvSpPr>
+        <p:spPr>
+          <a:xfrm>
+            <a:off x="804672" y="2596896"/>
+            <a:ext cx="9400032" cy="0"/>
+          </a:xfrm>
+          <a:prstGeom prst="line">
+            <a:avLst/>
+          </a:prstGeom>
+          <a:noFill/>
+          <a:ln w="12700">
+            <a:solidFill>
+              <a:srgbClr val="D8CFC4"/>
+            </a:solidFill>
+            <a:prstDash val="solid"/>
+          </a:ln>
+        </p:spPr>
+      </p:sp>
+      <p:sp>
+        <p:nvSpPr>
+          <p:cNvPr id="9" name="Text 6"/>
+          <p:cNvSpPr/>
+          <p:nvPr/>
+        </p:nvSpPr>
+        <p:spPr>
+          <a:xfrm>
+            <a:off x="804672" y="2852928"/>
+            <a:ext cx="530352" cy="621792"/>
+          </a:xfrm>
+          <a:prstGeom prst="rect">
+            <a:avLst/>
+          </a:prstGeom>
+          <a:noFill/>
+          <a:ln/>
+        </p:spPr>
+        <p:txBody>
+          <a:bodyPr wrap="square" lIns="0" tIns="0" rIns="0" bIns="0" rtlCol="0" anchor="ctr"/>
+          <a:lstStyle/>
+          <a:p>
+            <a:pPr indent="0" marL="0">
+              <a:buNone/>
+            </a:pPr>
+            <a:r>
+              <a:rPr lang="en-US" sz="3800" b="1" dirty="0">
+                <a:solidFill>
+                  <a:srgbClr val="D8CFC4"/>
+                </a:solidFill>
+                <a:latin typeface="Aptos Display" pitchFamily="34" charset="0"/>
+                <a:ea typeface="Aptos Display" pitchFamily="34" charset="-122"/>
+                <a:cs typeface="Aptos Display" pitchFamily="34" charset="-120"/>
+              </a:rPr>
+              <a:t>B</a:t>
+            </a:r>
+            <a:endParaRPr lang="en-US" sz="3800" dirty="0"/>
+          </a:p>
+        </p:txBody>
+      </p:sp>
+      <p:sp>
+        <p:nvSpPr>
+          <p:cNvPr id="10" name="Text 7"/>
+          <p:cNvSpPr/>
+          <p:nvPr/>
+        </p:nvSpPr>
+        <p:spPr>
+          <a:xfrm>
+            <a:off x="1463040" y="2816352"/>
+            <a:ext cx="7973568" cy="1426464"/>
+          </a:xfrm>
+          <a:prstGeom prst="rect">
+            <a:avLst/>
+          </a:prstGeom>
+          <a:noFill/>
+          <a:ln/>
+        </p:spPr>
+        <p:txBody>
+          <a:bodyPr wrap="square" lIns="0" tIns="0" rIns="0" bIns="0" rtlCol="0" anchor="ctr"/>
+          <a:lstStyle/>
+          <a:p>
+            <a:pPr indent="0" marL="0">
+              <a:buNone/>
+            </a:pPr>
+            <a:r>
+              <a:rPr lang="en-US" sz="1560" dirty="0">
+                <a:solidFill>
+                  <a:srgbClr val="102A43"/>
+                </a:solidFill>
+                <a:latin typeface="Aptos" pitchFamily="34" charset="0"/>
+                <a:ea typeface="Aptos" pitchFamily="34" charset="-122"/>
+                <a:cs typeface="Aptos" pitchFamily="34" charset="-120"/>
+              </a:rPr>
+              <a:t>¿Por qué el modelo relacional prohíbe las relaciones N:M directas?</a:t>
+            </a:r>
+            <a:endParaRPr lang="en-US" sz="1560" dirty="0"/>
+          </a:p>
+        </p:txBody>
+      </p:sp>
+      <p:sp>
+        <p:nvSpPr>
+          <p:cNvPr id="11" name="Shape 8"/>
+          <p:cNvSpPr/>
+          <p:nvPr/>
+        </p:nvSpPr>
+        <p:spPr>
+          <a:xfrm>
+            <a:off x="804672" y="4389120"/>
+            <a:ext cx="9400032" cy="0"/>
+          </a:xfrm>
+          <a:prstGeom prst="line">
+            <a:avLst/>
+          </a:prstGeom>
+          <a:noFill/>
+          <a:ln w="12700">
+            <a:solidFill>
+              <a:srgbClr val="D8CFC4"/>
+            </a:solidFill>
+            <a:prstDash val="solid"/>
+          </a:ln>
+        </p:spPr>
+      </p:sp>
+      <p:sp>
+        <p:nvSpPr>
+          <p:cNvPr id="12" name="Text 9"/>
+          <p:cNvSpPr/>
+          <p:nvPr/>
+        </p:nvSpPr>
+        <p:spPr>
+          <a:xfrm>
+            <a:off x="804672" y="4645152"/>
+            <a:ext cx="530352" cy="621792"/>
+          </a:xfrm>
+          <a:prstGeom prst="rect">
+            <a:avLst/>
+          </a:prstGeom>
+          <a:noFill/>
+          <a:ln/>
+        </p:spPr>
+        <p:txBody>
+          <a:bodyPr wrap="square" lIns="0" tIns="0" rIns="0" bIns="0" rtlCol="0" anchor="ctr"/>
+          <a:lstStyle/>
+          <a:p>
+            <a:pPr indent="0" marL="0">
+              <a:buNone/>
+            </a:pPr>
+            <a:r>
+              <a:rPr lang="en-US" sz="3800" b="1" dirty="0">
+                <a:solidFill>
+                  <a:srgbClr val="D8CFC4"/>
+                </a:solidFill>
+                <a:latin typeface="Aptos Display" pitchFamily="34" charset="0"/>
+                <a:ea typeface="Aptos Display" pitchFamily="34" charset="-122"/>
+                <a:cs typeface="Aptos Display" pitchFamily="34" charset="-120"/>
+              </a:rPr>
+              <a:t>C</a:t>
+            </a:r>
+            <a:endParaRPr lang="en-US" sz="3800" dirty="0"/>
+          </a:p>
+        </p:txBody>
+      </p:sp>
+      <p:sp>
+        <p:nvSpPr>
+          <p:cNvPr id="13" name="Text 10"/>
+          <p:cNvSpPr/>
+          <p:nvPr/>
+        </p:nvSpPr>
+        <p:spPr>
+          <a:xfrm>
+            <a:off x="1463040" y="4608576"/>
+            <a:ext cx="7973568" cy="1426464"/>
+          </a:xfrm>
+          <a:prstGeom prst="rect">
+            <a:avLst/>
+          </a:prstGeom>
+          <a:noFill/>
+          <a:ln/>
+        </p:spPr>
+        <p:txBody>
+          <a:bodyPr wrap="square" lIns="0" tIns="0" rIns="0" bIns="0" rtlCol="0" anchor="ctr"/>
+          <a:lstStyle/>
+          <a:p>
+            <a:pPr indent="0" marL="0">
+              <a:buNone/>
+            </a:pPr>
+            <a:r>
+              <a:rPr lang="en-US" sz="1560" dirty="0">
+                <a:solidFill>
+                  <a:srgbClr val="102A43"/>
+                </a:solidFill>
+                <a:latin typeface="Aptos" pitchFamily="34" charset="0"/>
+                <a:ea typeface="Aptos" pitchFamily="34" charset="-122"/>
+                <a:cs typeface="Aptos" pitchFamily="34" charset="-120"/>
+              </a:rPr>
+              <a:t>¿Cuál es la ventaja de validar datos con Pydantic antes de intentar guardarlos en Supabase?</a:t>
+            </a:r>
+            <a:endParaRPr lang="en-US" sz="1560" dirty="0"/>
+          </a:p>
+        </p:txBody>
+      </p:sp>
+    </p:spTree>
+  </p:cSld>
+  <p:clrMapOvr>
+    <a:masterClrMapping/>
+  </p:clrMapOvr>
+</p:sld>
+</file>
+
+<file path=ppt/slides/slide66.xml><?xml version="1.0" encoding="utf-8"?>
+<p:sld xmlns:a="http://schemas.openxmlformats.org/drawingml/2006/main" xmlns:r="http://schemas.openxmlformats.org/officeDocument/2006/relationships" xmlns:p="http://schemas.openxmlformats.org/presentationml/2006/main">
+  <p:cSld name="Slide 66">
+    <p:bg>
+      <p:bgPr>
+        <a:solidFill>
           <a:srgbClr val="102A43"/>
         </a:solidFill>
       </p:bgPr>
@@ -56076,1068 +58454,231 @@
         </p:nvSpPr>
         <p:spPr>
           <a:xfrm>
-            <a:off x="804672" y="621792"/>
-            <a:ext cx="1463040" cy="310896"/>
-          </a:xfrm>
-          <a:prstGeom prst="roundRect">
-            <a:avLst>
-              <a:gd name="adj" fmla="val 14706"/>
-            </a:avLst>
-          </a:prstGeom>
-          <a:solidFill>
-            <a:srgbClr val="D62027"/>
-          </a:solidFill>
-          <a:ln w="12700">
-            <a:solidFill>
-              <a:srgbClr val="D62027"/>
-            </a:solidFill>
-            <a:prstDash val="solid"/>
-          </a:ln>
-        </p:spPr>
-      </p:sp>
-      <p:sp>
-        <p:nvSpPr>
-          <p:cNvPr id="5" name="Text 2"/>
-          <p:cNvSpPr/>
-          <p:nvPr/>
-        </p:nvSpPr>
-        <p:spPr>
-          <a:xfrm>
-            <a:off x="914400" y="658368"/>
-            <a:ext cx="1243584" cy="201168"/>
-          </a:xfrm>
-          <a:prstGeom prst="rect">
-            <a:avLst/>
-          </a:prstGeom>
-          <a:noFill/>
-          <a:ln/>
-        </p:spPr>
-        <p:txBody>
-          <a:bodyPr wrap="square" lIns="0" tIns="0" rIns="0" bIns="0" rtlCol="0" anchor="ctr"/>
-          <a:lstStyle/>
-          <a:p>
-            <a:pPr algn="ctr" indent="0" marL="0">
-              <a:buNone/>
-            </a:pPr>
-            <a:r>
-              <a:rPr lang="en-US" sz="1060" b="1" dirty="0">
+            <a:off x="804672" y="1296619"/>
+            <a:ext cx="201168" cy="462686"/>
+          </a:xfrm>
+          <a:prstGeom prst="rect">
+            <a:avLst/>
+          </a:prstGeom>
+          <a:solidFill>
+            <a:srgbClr val="E0BC5A"/>
+          </a:solidFill>
+          <a:ln w="12700">
+            <a:solidFill>
+              <a:srgbClr val="E0BC5A"/>
+            </a:solidFill>
+            <a:prstDash val="solid"/>
+          </a:ln>
+        </p:spPr>
+      </p:sp>
+      <p:sp>
+        <p:nvSpPr>
+          <p:cNvPr id="5" name="Shape 2"/>
+          <p:cNvSpPr/>
+          <p:nvPr/>
+        </p:nvSpPr>
+        <p:spPr>
+          <a:xfrm>
+            <a:off x="1046074" y="1115568"/>
+            <a:ext cx="241402" cy="643738"/>
+          </a:xfrm>
+          <a:prstGeom prst="rect">
+            <a:avLst/>
+          </a:prstGeom>
+          <a:solidFill>
+            <a:srgbClr val="E0BC5A"/>
+          </a:solidFill>
+          <a:ln w="12700">
+            <a:solidFill>
+              <a:srgbClr val="E0BC5A"/>
+            </a:solidFill>
+            <a:prstDash val="solid"/>
+          </a:ln>
+        </p:spPr>
+      </p:sp>
+      <p:sp>
+        <p:nvSpPr>
+          <p:cNvPr id="6" name="Shape 3"/>
+          <p:cNvSpPr/>
+          <p:nvPr/>
+        </p:nvSpPr>
+        <p:spPr>
+          <a:xfrm>
+            <a:off x="1327709" y="1296619"/>
+            <a:ext cx="201168" cy="462686"/>
+          </a:xfrm>
+          <a:prstGeom prst="rect">
+            <a:avLst/>
+          </a:prstGeom>
+          <a:solidFill>
+            <a:srgbClr val="E0BC5A"/>
+          </a:solidFill>
+          <a:ln w="12700">
+            <a:solidFill>
+              <a:srgbClr val="E0BC5A"/>
+            </a:solidFill>
+            <a:prstDash val="solid"/>
+          </a:ln>
+        </p:spPr>
+      </p:sp>
+      <p:sp>
+        <p:nvSpPr>
+          <p:cNvPr id="7" name="Text 4"/>
+          <p:cNvSpPr/>
+          <p:nvPr/>
+        </p:nvSpPr>
+        <p:spPr>
+          <a:xfrm>
+            <a:off x="804672" y="1956816"/>
+            <a:ext cx="8412480" cy="1152144"/>
+          </a:xfrm>
+          <a:prstGeom prst="rect">
+            <a:avLst/>
+          </a:prstGeom>
+          <a:noFill/>
+          <a:ln/>
+        </p:spPr>
+        <p:txBody>
+          <a:bodyPr wrap="square" rtlCol="0" anchor="ctr"/>
+          <a:lstStyle/>
+          <a:p>
+            <a:pPr indent="0" marL="0">
+              <a:buNone/>
+            </a:pPr>
+            <a:r>
+              <a:rPr lang="en-US" sz="3600" b="1" dirty="0">
                 <a:solidFill>
                   <a:srgbClr val="FFFFFF"/>
+                </a:solidFill>
+                <a:latin typeface="Aptos Display" pitchFamily="34" charset="0"/>
+                <a:ea typeface="Aptos Display" pitchFamily="34" charset="-122"/>
+                <a:cs typeface="Aptos Display" pitchFamily="34" charset="-120"/>
+              </a:rPr>
+              <a:t>Mañana: IA en Desarrollo</a:t>
+            </a:r>
+            <a:endParaRPr lang="en-US" sz="3600" dirty="0"/>
+          </a:p>
+          <a:p>
+            <a:pPr indent="0" marL="0">
+              <a:buNone/>
+            </a:pPr>
+            <a:r>
+              <a:rPr lang="en-US" sz="3600" b="1" dirty="0">
+                <a:solidFill>
+                  <a:srgbClr val="FFFFFF"/>
+                </a:solidFill>
+                <a:latin typeface="Aptos Display" pitchFamily="34" charset="0"/>
+                <a:ea typeface="Aptos Display" pitchFamily="34" charset="-122"/>
+                <a:cs typeface="Aptos Display" pitchFamily="34" charset="-120"/>
+              </a:rPr>
+              <a:t>Intensivo de Backend</a:t>
+            </a:r>
+            <a:endParaRPr lang="en-US" sz="3600" dirty="0"/>
+          </a:p>
+        </p:txBody>
+      </p:sp>
+      <p:sp>
+        <p:nvSpPr>
+          <p:cNvPr id="8" name="Text 5"/>
+          <p:cNvSpPr/>
+          <p:nvPr/>
+        </p:nvSpPr>
+        <p:spPr>
+          <a:xfrm>
+            <a:off x="804672" y="3310128"/>
+            <a:ext cx="7498080" cy="731520"/>
+          </a:xfrm>
+          <a:prstGeom prst="rect">
+            <a:avLst/>
+          </a:prstGeom>
+          <a:noFill/>
+          <a:ln/>
+        </p:spPr>
+        <p:txBody>
+          <a:bodyPr wrap="square" rtlCol="0" anchor="ctr"/>
+          <a:lstStyle/>
+          <a:p>
+            <a:pPr indent="0" marL="0">
+              <a:buNone/>
+            </a:pPr>
+            <a:r>
+              <a:rPr lang="en-US" sz="1520" dirty="0">
+                <a:solidFill>
+                  <a:srgbClr val="DCE6F2"/>
                 </a:solidFill>
                 <a:latin typeface="Aptos" pitchFamily="34" charset="0"/>
                 <a:ea typeface="Aptos" pitchFamily="34" charset="-122"/>
                 <a:cs typeface="Aptos" pitchFamily="34" charset="-120"/>
               </a:rPr>
-              <a:t>CIERRE DE CLASE</a:t>
-            </a:r>
-            <a:endParaRPr lang="en-US" sz="1060" dirty="0"/>
-          </a:p>
-        </p:txBody>
-      </p:sp>
-      <p:sp>
-        <p:nvSpPr>
-          <p:cNvPr id="6" name="Text 3"/>
-          <p:cNvSpPr/>
-          <p:nvPr/>
-        </p:nvSpPr>
-        <p:spPr>
-          <a:xfrm>
-            <a:off x="804672" y="1463040"/>
-            <a:ext cx="8412480" cy="914400"/>
-          </a:xfrm>
-          <a:prstGeom prst="rect">
-            <a:avLst/>
-          </a:prstGeom>
-          <a:noFill/>
-          <a:ln/>
-        </p:spPr>
-        <p:txBody>
-          <a:bodyPr wrap="square" rtlCol="0" anchor="t"/>
-          <a:lstStyle/>
-          <a:p>
-            <a:pPr indent="0" marL="0">
-              <a:buNone/>
-            </a:pPr>
-            <a:r>
-              <a:rPr lang="en-US" sz="3800" b="1" dirty="0">
-                <a:solidFill>
-                  <a:srgbClr val="FFFFFF"/>
+              <a:t>Aprenderemos a usar agentes para acelerar la creación de modelos, validación de reglas y generación de código crítico.</a:t>
+            </a:r>
+            <a:endParaRPr lang="en-US" sz="1520" dirty="0"/>
+          </a:p>
+        </p:txBody>
+      </p:sp>
+      <p:sp>
+        <p:nvSpPr>
+          <p:cNvPr id="9" name="Shape 6"/>
+          <p:cNvSpPr/>
+          <p:nvPr/>
+        </p:nvSpPr>
+        <p:spPr>
+          <a:xfrm>
+            <a:off x="804672" y="5321808"/>
+            <a:ext cx="9381744" cy="749808"/>
+          </a:xfrm>
+          <a:prstGeom prst="roundRect">
+            <a:avLst>
+              <a:gd name="adj" fmla="val 4878"/>
+            </a:avLst>
+          </a:prstGeom>
+          <a:solidFill>
+            <a:srgbClr val="E0BC5A"/>
+          </a:solidFill>
+          <a:ln w="12700">
+            <a:solidFill>
+              <a:srgbClr val="E0BC5A"/>
+            </a:solidFill>
+            <a:prstDash val="solid"/>
+          </a:ln>
+        </p:spPr>
+      </p:sp>
+      <p:sp>
+        <p:nvSpPr>
+          <p:cNvPr id="10" name="Text 7"/>
+          <p:cNvSpPr/>
+          <p:nvPr/>
+        </p:nvSpPr>
+        <p:spPr>
+          <a:xfrm>
+            <a:off x="1005840" y="5486400"/>
+            <a:ext cx="8979408" cy="420624"/>
+          </a:xfrm>
+          <a:prstGeom prst="rect">
+            <a:avLst/>
+          </a:prstGeom>
+          <a:noFill/>
+          <a:ln/>
+        </p:spPr>
+        <p:txBody>
+          <a:bodyPr wrap="square" lIns="0" tIns="0" rIns="0" bIns="0" rtlCol="0" anchor="ctr"/>
+          <a:lstStyle/>
+          <a:p>
+            <a:pPr algn="ctr" indent="0" marL="0">
+              <a:buNone/>
+            </a:pPr>
+            <a:r>
+              <a:rPr lang="en-US" sz="2400" b="1" dirty="0">
+                <a:solidFill>
+                  <a:srgbClr val="102A43"/>
                 </a:solidFill>
                 <a:latin typeface="Aptos Display" pitchFamily="34" charset="0"/>
                 <a:ea typeface="Aptos Display" pitchFamily="34" charset="-122"/>
                 <a:cs typeface="Aptos Display" pitchFamily="34" charset="-120"/>
               </a:rPr>
-              <a:t>Resumen de la Sesión</a:t>
-            </a:r>
-            <a:endParaRPr lang="en-US" sz="3800" dirty="0"/>
-          </a:p>
-        </p:txBody>
-      </p:sp>
-      <p:sp>
-        <p:nvSpPr>
-          <p:cNvPr id="7" name="Shape 4"/>
-          <p:cNvSpPr/>
-          <p:nvPr/>
-        </p:nvSpPr>
-        <p:spPr>
-          <a:xfrm>
-            <a:off x="804672" y="2560320"/>
-            <a:ext cx="9381744" cy="2743200"/>
-          </a:xfrm>
-          <a:prstGeom prst="roundRect">
-            <a:avLst>
-              <a:gd name="adj" fmla="val 1333"/>
-            </a:avLst>
-          </a:prstGeom>
-          <a:solidFill>
-            <a:srgbClr val="FFFFFF"/>
-          </a:solidFill>
-          <a:ln w="12700">
-            <a:solidFill>
-              <a:srgbClr val="D8CFC4"/>
-            </a:solidFill>
-            <a:prstDash val="solid"/>
-          </a:ln>
-        </p:spPr>
-      </p:sp>
-      <p:sp>
-        <p:nvSpPr>
-          <p:cNvPr id="8" name="Shape 5"/>
-          <p:cNvSpPr/>
-          <p:nvPr/>
-        </p:nvSpPr>
-        <p:spPr>
-          <a:xfrm>
-            <a:off x="932688" y="2688336"/>
-            <a:ext cx="9125712" cy="310896"/>
-          </a:xfrm>
-          <a:prstGeom prst="roundRect">
-            <a:avLst>
-              <a:gd name="adj" fmla="val 8824"/>
-            </a:avLst>
-          </a:prstGeom>
-          <a:solidFill>
-            <a:srgbClr val="EDE6DA"/>
-          </a:solidFill>
-          <a:ln w="12700">
-            <a:solidFill>
-              <a:srgbClr val="EDE6DA"/>
-            </a:solidFill>
-            <a:prstDash val="solid"/>
-          </a:ln>
-        </p:spPr>
-      </p:sp>
-      <p:sp>
-        <p:nvSpPr>
-          <p:cNvPr id="9" name="Text 6"/>
-          <p:cNvSpPr/>
-          <p:nvPr/>
-        </p:nvSpPr>
-        <p:spPr>
-          <a:xfrm>
-            <a:off x="1042416" y="2761488"/>
-            <a:ext cx="8906256" cy="201168"/>
-          </a:xfrm>
-          <a:prstGeom prst="rect">
-            <a:avLst/>
-          </a:prstGeom>
-          <a:noFill/>
-          <a:ln/>
-        </p:spPr>
-        <p:txBody>
-          <a:bodyPr wrap="square" lIns="0" tIns="0" rIns="0" bIns="0" rtlCol="0" anchor="ctr"/>
-          <a:lstStyle/>
-          <a:p>
-            <a:pPr indent="0" marL="0">
-              <a:buNone/>
-            </a:pPr>
-            <a:r>
-              <a:rPr lang="en-US" sz="980" b="1" dirty="0">
-                <a:solidFill>
-                  <a:srgbClr val="102A43"/>
-                </a:solidFill>
-                <a:latin typeface="Aptos" pitchFamily="34" charset="0"/>
-                <a:ea typeface="Aptos" pitchFamily="34" charset="-122"/>
-                <a:cs typeface="Aptos" pitchFamily="34" charset="-120"/>
-              </a:rPr>
-              <a:t>Lo que logramos hoy</a:t>
-            </a:r>
-            <a:endParaRPr lang="en-US" sz="980" dirty="0"/>
-          </a:p>
-        </p:txBody>
-      </p:sp>
-      <p:sp>
-        <p:nvSpPr>
-          <p:cNvPr id="10" name="Shape 7"/>
-          <p:cNvSpPr/>
-          <p:nvPr/>
-        </p:nvSpPr>
-        <p:spPr>
-          <a:xfrm>
-            <a:off x="950976" y="3072384"/>
-            <a:ext cx="4453128" cy="905256"/>
-          </a:xfrm>
-          <a:prstGeom prst="roundRect">
-            <a:avLst>
-              <a:gd name="adj" fmla="val 4040"/>
-            </a:avLst>
-          </a:prstGeom>
-          <a:solidFill>
-            <a:srgbClr val="E6EEF7"/>
-          </a:solidFill>
-          <a:ln w="12700">
-            <a:solidFill>
-              <a:srgbClr val="D8CFC4"/>
-            </a:solidFill>
-            <a:prstDash val="solid"/>
-          </a:ln>
-        </p:spPr>
-      </p:sp>
-      <p:sp>
-        <p:nvSpPr>
-          <p:cNvPr id="11" name="Shape 8"/>
-          <p:cNvSpPr/>
-          <p:nvPr/>
-        </p:nvSpPr>
-        <p:spPr>
-          <a:xfrm>
-            <a:off x="1060704" y="3200400"/>
-            <a:ext cx="384048" cy="219456"/>
-          </a:xfrm>
-          <a:prstGeom prst="roundRect">
-            <a:avLst>
-              <a:gd name="adj" fmla="val 20833"/>
-            </a:avLst>
-          </a:prstGeom>
-          <a:solidFill>
-            <a:srgbClr val="102A43"/>
-          </a:solidFill>
-          <a:ln w="12700">
-            <a:solidFill>
-              <a:srgbClr val="102A43"/>
-            </a:solidFill>
-            <a:prstDash val="solid"/>
-          </a:ln>
-        </p:spPr>
-      </p:sp>
-      <p:sp>
-        <p:nvSpPr>
-          <p:cNvPr id="12" name="Text 9"/>
-          <p:cNvSpPr/>
-          <p:nvPr/>
-        </p:nvSpPr>
-        <p:spPr>
-          <a:xfrm>
-            <a:off x="1060704" y="3246120"/>
-            <a:ext cx="384048" cy="73152"/>
-          </a:xfrm>
-          <a:prstGeom prst="rect">
-            <a:avLst/>
-          </a:prstGeom>
-          <a:noFill/>
-          <a:ln/>
-        </p:spPr>
-        <p:txBody>
-          <a:bodyPr wrap="square" lIns="0" tIns="0" rIns="0" bIns="0" rtlCol="0" anchor="ctr"/>
-          <a:lstStyle/>
-          <a:p>
-            <a:pPr algn="ctr" indent="0" marL="0">
-              <a:buNone/>
-            </a:pPr>
-            <a:r>
-              <a:rPr lang="en-US" sz="780" b="1" dirty="0">
-                <a:solidFill>
-                  <a:srgbClr val="102A43"/>
-                </a:solidFill>
-                <a:latin typeface="Aptos" pitchFamily="34" charset="0"/>
-                <a:ea typeface="Aptos" pitchFamily="34" charset="-122"/>
-                <a:cs typeface="Aptos" pitchFamily="34" charset="-120"/>
-              </a:rPr>
-              <a:t>OK</a:t>
-            </a:r>
-            <a:endParaRPr lang="en-US" sz="780" dirty="0"/>
-          </a:p>
-        </p:txBody>
-      </p:sp>
-      <p:sp>
-        <p:nvSpPr>
-          <p:cNvPr id="13" name="Shape 10"/>
-          <p:cNvSpPr/>
-          <p:nvPr/>
-        </p:nvSpPr>
-        <p:spPr>
-          <a:xfrm>
-            <a:off x="1572768" y="3200400"/>
-            <a:ext cx="73152" cy="649224"/>
-          </a:xfrm>
-          <a:prstGeom prst="rect">
-            <a:avLst/>
-          </a:prstGeom>
-          <a:solidFill>
-            <a:srgbClr val="102A43"/>
-          </a:solidFill>
-          <a:ln w="12700">
-            <a:solidFill>
-              <a:srgbClr val="102A43"/>
-            </a:solidFill>
-            <a:prstDash val="solid"/>
-          </a:ln>
-        </p:spPr>
-      </p:sp>
-      <p:sp>
-        <p:nvSpPr>
-          <p:cNvPr id="14" name="Text 11"/>
-          <p:cNvSpPr/>
-          <p:nvPr/>
-        </p:nvSpPr>
-        <p:spPr>
-          <a:xfrm>
-            <a:off x="1773936" y="3218688"/>
-            <a:ext cx="3502152" cy="164592"/>
-          </a:xfrm>
-          <a:prstGeom prst="rect">
-            <a:avLst/>
-          </a:prstGeom>
-          <a:noFill/>
-          <a:ln/>
-        </p:spPr>
-        <p:txBody>
-          <a:bodyPr wrap="square" lIns="0" tIns="0" rIns="0" bIns="0" rtlCol="0" anchor="ctr"/>
-          <a:lstStyle/>
-          <a:p>
-            <a:pPr indent="0" marL="0">
-              <a:buNone/>
-            </a:pPr>
-            <a:r>
-              <a:rPr lang="en-US" sz="1360" b="1" dirty="0">
-                <a:solidFill>
-                  <a:srgbClr val="102A43"/>
-                </a:solidFill>
-                <a:latin typeface="Aptos Display" pitchFamily="34" charset="0"/>
-                <a:ea typeface="Aptos Display" pitchFamily="34" charset="-122"/>
-                <a:cs typeface="Aptos Display" pitchFamily="34" charset="-120"/>
-              </a:rPr>
-              <a:t>Modelado (B1)</a:t>
-            </a:r>
-            <a:endParaRPr lang="en-US" sz="1360" dirty="0"/>
-          </a:p>
-        </p:txBody>
-      </p:sp>
-      <p:sp>
-        <p:nvSpPr>
-          <p:cNvPr id="15" name="Text 12"/>
-          <p:cNvSpPr/>
-          <p:nvPr/>
-        </p:nvSpPr>
-        <p:spPr>
-          <a:xfrm>
-            <a:off x="1773936" y="3511296"/>
-            <a:ext cx="3502152" cy="320040"/>
-          </a:xfrm>
-          <a:prstGeom prst="rect">
-            <a:avLst/>
-          </a:prstGeom>
-          <a:noFill/>
-          <a:ln/>
-        </p:spPr>
-        <p:txBody>
-          <a:bodyPr wrap="square" lIns="0" tIns="0" rIns="0" bIns="0" rtlCol="0" anchor="t"/>
-          <a:lstStyle/>
-          <a:p>
-            <a:pPr indent="0" marL="0">
-              <a:buNone/>
-            </a:pPr>
-            <a:r>
-              <a:rPr lang="en-US" sz="1060" dirty="0">
-                <a:solidFill>
-                  <a:srgbClr val="243B53"/>
-                </a:solidFill>
-                <a:latin typeface="Aptos" pitchFamily="34" charset="0"/>
-                <a:ea typeface="Aptos" pitchFamily="34" charset="-122"/>
-                <a:cs typeface="Aptos" pitchFamily="34" charset="-120"/>
-              </a:rPr>
-              <a:t>Entendimos Entidades, Atributos y Primary Keys.</a:t>
-            </a:r>
-            <a:endParaRPr lang="en-US" sz="1060" dirty="0"/>
-          </a:p>
-        </p:txBody>
-      </p:sp>
-      <p:sp>
-        <p:nvSpPr>
-          <p:cNvPr id="16" name="Shape 13"/>
-          <p:cNvSpPr/>
-          <p:nvPr/>
-        </p:nvSpPr>
-        <p:spPr>
-          <a:xfrm>
-            <a:off x="5586984" y="3072384"/>
-            <a:ext cx="4453128" cy="905256"/>
-          </a:xfrm>
-          <a:prstGeom prst="roundRect">
-            <a:avLst>
-              <a:gd name="adj" fmla="val 4040"/>
-            </a:avLst>
-          </a:prstGeom>
-          <a:solidFill>
-            <a:srgbClr val="E6EEF7"/>
-          </a:solidFill>
-          <a:ln w="12700">
-            <a:solidFill>
-              <a:srgbClr val="D8CFC4"/>
-            </a:solidFill>
-            <a:prstDash val="solid"/>
-          </a:ln>
-        </p:spPr>
-      </p:sp>
-      <p:sp>
-        <p:nvSpPr>
-          <p:cNvPr id="17" name="Shape 14"/>
-          <p:cNvSpPr/>
-          <p:nvPr/>
-        </p:nvSpPr>
-        <p:spPr>
-          <a:xfrm>
-            <a:off x="5696712" y="3200400"/>
-            <a:ext cx="384048" cy="219456"/>
-          </a:xfrm>
-          <a:prstGeom prst="roundRect">
-            <a:avLst>
-              <a:gd name="adj" fmla="val 20833"/>
-            </a:avLst>
-          </a:prstGeom>
-          <a:solidFill>
-            <a:srgbClr val="102A43"/>
-          </a:solidFill>
-          <a:ln w="12700">
-            <a:solidFill>
-              <a:srgbClr val="102A43"/>
-            </a:solidFill>
-            <a:prstDash val="solid"/>
-          </a:ln>
-        </p:spPr>
-      </p:sp>
-      <p:sp>
-        <p:nvSpPr>
-          <p:cNvPr id="18" name="Text 15"/>
-          <p:cNvSpPr/>
-          <p:nvPr/>
-        </p:nvSpPr>
-        <p:spPr>
-          <a:xfrm>
-            <a:off x="5696712" y="3246120"/>
-            <a:ext cx="384048" cy="73152"/>
-          </a:xfrm>
-          <a:prstGeom prst="rect">
-            <a:avLst/>
-          </a:prstGeom>
-          <a:noFill/>
-          <a:ln/>
-        </p:spPr>
-        <p:txBody>
-          <a:bodyPr wrap="square" lIns="0" tIns="0" rIns="0" bIns="0" rtlCol="0" anchor="ctr"/>
-          <a:lstStyle/>
-          <a:p>
-            <a:pPr algn="ctr" indent="0" marL="0">
-              <a:buNone/>
-            </a:pPr>
-            <a:r>
-              <a:rPr lang="en-US" sz="780" b="1" dirty="0">
-                <a:solidFill>
-                  <a:srgbClr val="102A43"/>
-                </a:solidFill>
-                <a:latin typeface="Aptos" pitchFamily="34" charset="0"/>
-                <a:ea typeface="Aptos" pitchFamily="34" charset="-122"/>
-                <a:cs typeface="Aptos" pitchFamily="34" charset="-120"/>
-              </a:rPr>
-              <a:t>OK</a:t>
-            </a:r>
-            <a:endParaRPr lang="en-US" sz="780" dirty="0"/>
-          </a:p>
-        </p:txBody>
-      </p:sp>
-      <p:sp>
-        <p:nvSpPr>
-          <p:cNvPr id="19" name="Shape 16"/>
-          <p:cNvSpPr/>
-          <p:nvPr/>
-        </p:nvSpPr>
-        <p:spPr>
-          <a:xfrm>
-            <a:off x="6208776" y="3200400"/>
-            <a:ext cx="73152" cy="649224"/>
-          </a:xfrm>
-          <a:prstGeom prst="rect">
-            <a:avLst/>
-          </a:prstGeom>
-          <a:solidFill>
-            <a:srgbClr val="102A43"/>
-          </a:solidFill>
-          <a:ln w="12700">
-            <a:solidFill>
-              <a:srgbClr val="102A43"/>
-            </a:solidFill>
-            <a:prstDash val="solid"/>
-          </a:ln>
-        </p:spPr>
-      </p:sp>
-      <p:sp>
-        <p:nvSpPr>
-          <p:cNvPr id="20" name="Text 17"/>
-          <p:cNvSpPr/>
-          <p:nvPr/>
-        </p:nvSpPr>
-        <p:spPr>
-          <a:xfrm>
-            <a:off x="6409944" y="3218688"/>
-            <a:ext cx="3502152" cy="164592"/>
-          </a:xfrm>
-          <a:prstGeom prst="rect">
-            <a:avLst/>
-          </a:prstGeom>
-          <a:noFill/>
-          <a:ln/>
-        </p:spPr>
-        <p:txBody>
-          <a:bodyPr wrap="square" lIns="0" tIns="0" rIns="0" bIns="0" rtlCol="0" anchor="ctr"/>
-          <a:lstStyle/>
-          <a:p>
-            <a:pPr indent="0" marL="0">
-              <a:buNone/>
-            </a:pPr>
-            <a:r>
-              <a:rPr lang="en-US" sz="1360" b="1" dirty="0">
-                <a:solidFill>
-                  <a:srgbClr val="102A43"/>
-                </a:solidFill>
-                <a:latin typeface="Aptos Display" pitchFamily="34" charset="0"/>
-                <a:ea typeface="Aptos Display" pitchFamily="34" charset="-122"/>
-                <a:cs typeface="Aptos Display" pitchFamily="34" charset="-120"/>
-              </a:rPr>
-              <a:t>Relaciones (B2)</a:t>
-            </a:r>
-            <a:endParaRPr lang="en-US" sz="1360" dirty="0"/>
-          </a:p>
-        </p:txBody>
-      </p:sp>
-      <p:sp>
-        <p:nvSpPr>
-          <p:cNvPr id="21" name="Text 18"/>
-          <p:cNvSpPr/>
-          <p:nvPr/>
-        </p:nvSpPr>
-        <p:spPr>
-          <a:xfrm>
-            <a:off x="6409944" y="3511296"/>
-            <a:ext cx="3502152" cy="320040"/>
-          </a:xfrm>
-          <a:prstGeom prst="rect">
-            <a:avLst/>
-          </a:prstGeom>
-          <a:noFill/>
-          <a:ln/>
-        </p:spPr>
-        <p:txBody>
-          <a:bodyPr wrap="square" lIns="0" tIns="0" rIns="0" bIns="0" rtlCol="0" anchor="t"/>
-          <a:lstStyle/>
-          <a:p>
-            <a:pPr indent="0" marL="0">
-              <a:buNone/>
-            </a:pPr>
-            <a:r>
-              <a:rPr lang="en-US" sz="1060" dirty="0">
-                <a:solidFill>
-                  <a:srgbClr val="243B53"/>
-                </a:solidFill>
-                <a:latin typeface="Aptos" pitchFamily="34" charset="0"/>
-                <a:ea typeface="Aptos" pitchFamily="34" charset="-122"/>
-                <a:cs typeface="Aptos" pitchFamily="34" charset="-120"/>
-              </a:rPr>
-              <a:t>Conectamos tablas con FK y cardinalidad.</a:t>
-            </a:r>
-            <a:endParaRPr lang="en-US" sz="1060" dirty="0"/>
-          </a:p>
-        </p:txBody>
-      </p:sp>
-      <p:sp>
-        <p:nvSpPr>
-          <p:cNvPr id="22" name="Shape 19"/>
-          <p:cNvSpPr/>
-          <p:nvPr/>
-        </p:nvSpPr>
-        <p:spPr>
-          <a:xfrm>
-            <a:off x="950976" y="4142232"/>
-            <a:ext cx="4453128" cy="905256"/>
-          </a:xfrm>
-          <a:prstGeom prst="roundRect">
-            <a:avLst>
-              <a:gd name="adj" fmla="val 4040"/>
-            </a:avLst>
-          </a:prstGeom>
-          <a:solidFill>
-            <a:srgbClr val="E6EEF7"/>
-          </a:solidFill>
-          <a:ln w="12700">
-            <a:solidFill>
-              <a:srgbClr val="D8CFC4"/>
-            </a:solidFill>
-            <a:prstDash val="solid"/>
-          </a:ln>
-        </p:spPr>
-      </p:sp>
-      <p:sp>
-        <p:nvSpPr>
-          <p:cNvPr id="23" name="Shape 20"/>
-          <p:cNvSpPr/>
-          <p:nvPr/>
-        </p:nvSpPr>
-        <p:spPr>
-          <a:xfrm>
-            <a:off x="1060704" y="4270248"/>
-            <a:ext cx="384048" cy="219456"/>
-          </a:xfrm>
-          <a:prstGeom prst="roundRect">
-            <a:avLst>
-              <a:gd name="adj" fmla="val 20833"/>
-            </a:avLst>
-          </a:prstGeom>
-          <a:solidFill>
-            <a:srgbClr val="102A43"/>
-          </a:solidFill>
-          <a:ln w="12700">
-            <a:solidFill>
-              <a:srgbClr val="102A43"/>
-            </a:solidFill>
-            <a:prstDash val="solid"/>
-          </a:ln>
-        </p:spPr>
-      </p:sp>
-      <p:sp>
-        <p:nvSpPr>
-          <p:cNvPr id="24" name="Text 21"/>
-          <p:cNvSpPr/>
-          <p:nvPr/>
-        </p:nvSpPr>
-        <p:spPr>
-          <a:xfrm>
-            <a:off x="1060704" y="4315968"/>
-            <a:ext cx="384048" cy="73152"/>
-          </a:xfrm>
-          <a:prstGeom prst="rect">
-            <a:avLst/>
-          </a:prstGeom>
-          <a:noFill/>
-          <a:ln/>
-        </p:spPr>
-        <p:txBody>
-          <a:bodyPr wrap="square" lIns="0" tIns="0" rIns="0" bIns="0" rtlCol="0" anchor="ctr"/>
-          <a:lstStyle/>
-          <a:p>
-            <a:pPr algn="ctr" indent="0" marL="0">
-              <a:buNone/>
-            </a:pPr>
-            <a:r>
-              <a:rPr lang="en-US" sz="780" b="1" dirty="0">
-                <a:solidFill>
-                  <a:srgbClr val="102A43"/>
-                </a:solidFill>
-                <a:latin typeface="Aptos" pitchFamily="34" charset="0"/>
-                <a:ea typeface="Aptos" pitchFamily="34" charset="-122"/>
-                <a:cs typeface="Aptos" pitchFamily="34" charset="-120"/>
-              </a:rPr>
-              <a:t>OK</a:t>
-            </a:r>
-            <a:endParaRPr lang="en-US" sz="780" dirty="0"/>
-          </a:p>
-        </p:txBody>
-      </p:sp>
-      <p:sp>
-        <p:nvSpPr>
-          <p:cNvPr id="25" name="Shape 22"/>
-          <p:cNvSpPr/>
-          <p:nvPr/>
-        </p:nvSpPr>
-        <p:spPr>
-          <a:xfrm>
-            <a:off x="1572768" y="4270248"/>
-            <a:ext cx="73152" cy="649224"/>
-          </a:xfrm>
-          <a:prstGeom prst="rect">
-            <a:avLst/>
-          </a:prstGeom>
-          <a:solidFill>
-            <a:srgbClr val="102A43"/>
-          </a:solidFill>
-          <a:ln w="12700">
-            <a:solidFill>
-              <a:srgbClr val="102A43"/>
-            </a:solidFill>
-            <a:prstDash val="solid"/>
-          </a:ln>
-        </p:spPr>
-      </p:sp>
-      <p:sp>
-        <p:nvSpPr>
-          <p:cNvPr id="26" name="Text 23"/>
-          <p:cNvSpPr/>
-          <p:nvPr/>
-        </p:nvSpPr>
-        <p:spPr>
-          <a:xfrm>
-            <a:off x="1773936" y="4288536"/>
-            <a:ext cx="3502152" cy="164592"/>
-          </a:xfrm>
-          <a:prstGeom prst="rect">
-            <a:avLst/>
-          </a:prstGeom>
-          <a:noFill/>
-          <a:ln/>
-        </p:spPr>
-        <p:txBody>
-          <a:bodyPr wrap="square" lIns="0" tIns="0" rIns="0" bIns="0" rtlCol="0" anchor="ctr"/>
-          <a:lstStyle/>
-          <a:p>
-            <a:pPr indent="0" marL="0">
-              <a:buNone/>
-            </a:pPr>
-            <a:r>
-              <a:rPr lang="en-US" sz="1360" b="1" dirty="0">
-                <a:solidFill>
-                  <a:srgbClr val="102A43"/>
-                </a:solidFill>
-                <a:latin typeface="Aptos Display" pitchFamily="34" charset="0"/>
-                <a:ea typeface="Aptos Display" pitchFamily="34" charset="-122"/>
-                <a:cs typeface="Aptos Display" pitchFamily="34" charset="-120"/>
-              </a:rPr>
-              <a:t>Normalización (B3)</a:t>
-            </a:r>
-            <a:endParaRPr lang="en-US" sz="1360" dirty="0"/>
-          </a:p>
-        </p:txBody>
-      </p:sp>
-      <p:sp>
-        <p:nvSpPr>
-          <p:cNvPr id="27" name="Text 24"/>
-          <p:cNvSpPr/>
-          <p:nvPr/>
-        </p:nvSpPr>
-        <p:spPr>
-          <a:xfrm>
-            <a:off x="1773936" y="4581144"/>
-            <a:ext cx="3502152" cy="320040"/>
-          </a:xfrm>
-          <a:prstGeom prst="rect">
-            <a:avLst/>
-          </a:prstGeom>
-          <a:noFill/>
-          <a:ln/>
-        </p:spPr>
-        <p:txBody>
-          <a:bodyPr wrap="square" lIns="0" tIns="0" rIns="0" bIns="0" rtlCol="0" anchor="t"/>
-          <a:lstStyle/>
-          <a:p>
-            <a:pPr indent="0" marL="0">
-              <a:buNone/>
-            </a:pPr>
-            <a:r>
-              <a:rPr lang="en-US" sz="1060" dirty="0">
-                <a:solidFill>
-                  <a:srgbClr val="243B53"/>
-                </a:solidFill>
-                <a:latin typeface="Aptos" pitchFamily="34" charset="0"/>
-                <a:ea typeface="Aptos" pitchFamily="34" charset="-122"/>
-                <a:cs typeface="Aptos" pitchFamily="34" charset="-120"/>
-              </a:rPr>
-              <a:t>Limpiamos la arquitectura (1FN, 2FN, 3FN).</a:t>
-            </a:r>
-            <a:endParaRPr lang="en-US" sz="1060" dirty="0"/>
-          </a:p>
-        </p:txBody>
-      </p:sp>
-      <p:sp>
-        <p:nvSpPr>
-          <p:cNvPr id="28" name="Shape 25"/>
-          <p:cNvSpPr/>
-          <p:nvPr/>
-        </p:nvSpPr>
-        <p:spPr>
-          <a:xfrm>
-            <a:off x="5586984" y="4142232"/>
-            <a:ext cx="4453128" cy="905256"/>
-          </a:xfrm>
-          <a:prstGeom prst="roundRect">
-            <a:avLst>
-              <a:gd name="adj" fmla="val 4040"/>
-            </a:avLst>
-          </a:prstGeom>
-          <a:solidFill>
-            <a:srgbClr val="E6EEF7"/>
-          </a:solidFill>
-          <a:ln w="12700">
-            <a:solidFill>
-              <a:srgbClr val="D8CFC4"/>
-            </a:solidFill>
-            <a:prstDash val="solid"/>
-          </a:ln>
-        </p:spPr>
-      </p:sp>
-      <p:sp>
-        <p:nvSpPr>
-          <p:cNvPr id="29" name="Shape 26"/>
-          <p:cNvSpPr/>
-          <p:nvPr/>
-        </p:nvSpPr>
-        <p:spPr>
-          <a:xfrm>
-            <a:off x="5696712" y="4270248"/>
-            <a:ext cx="384048" cy="219456"/>
-          </a:xfrm>
-          <a:prstGeom prst="roundRect">
-            <a:avLst>
-              <a:gd name="adj" fmla="val 20833"/>
-            </a:avLst>
-          </a:prstGeom>
-          <a:solidFill>
-            <a:srgbClr val="102A43"/>
-          </a:solidFill>
-          <a:ln w="12700">
-            <a:solidFill>
-              <a:srgbClr val="102A43"/>
-            </a:solidFill>
-            <a:prstDash val="solid"/>
-          </a:ln>
-        </p:spPr>
-      </p:sp>
-      <p:sp>
-        <p:nvSpPr>
-          <p:cNvPr id="30" name="Text 27"/>
-          <p:cNvSpPr/>
-          <p:nvPr/>
-        </p:nvSpPr>
-        <p:spPr>
-          <a:xfrm>
-            <a:off x="5696712" y="4315968"/>
-            <a:ext cx="384048" cy="73152"/>
-          </a:xfrm>
-          <a:prstGeom prst="rect">
-            <a:avLst/>
-          </a:prstGeom>
-          <a:noFill/>
-          <a:ln/>
-        </p:spPr>
-        <p:txBody>
-          <a:bodyPr wrap="square" lIns="0" tIns="0" rIns="0" bIns="0" rtlCol="0" anchor="ctr"/>
-          <a:lstStyle/>
-          <a:p>
-            <a:pPr algn="ctr" indent="0" marL="0">
-              <a:buNone/>
-            </a:pPr>
-            <a:r>
-              <a:rPr lang="en-US" sz="780" b="1" dirty="0">
-                <a:solidFill>
-                  <a:srgbClr val="102A43"/>
-                </a:solidFill>
-                <a:latin typeface="Aptos" pitchFamily="34" charset="0"/>
-                <a:ea typeface="Aptos" pitchFamily="34" charset="-122"/>
-                <a:cs typeface="Aptos" pitchFamily="34" charset="-120"/>
-              </a:rPr>
-              <a:t>OK</a:t>
-            </a:r>
-            <a:endParaRPr lang="en-US" sz="780" dirty="0"/>
-          </a:p>
-        </p:txBody>
-      </p:sp>
-      <p:sp>
-        <p:nvSpPr>
-          <p:cNvPr id="31" name="Shape 28"/>
-          <p:cNvSpPr/>
-          <p:nvPr/>
-        </p:nvSpPr>
-        <p:spPr>
-          <a:xfrm>
-            <a:off x="6208776" y="4270248"/>
-            <a:ext cx="73152" cy="649224"/>
-          </a:xfrm>
-          <a:prstGeom prst="rect">
-            <a:avLst/>
-          </a:prstGeom>
-          <a:solidFill>
-            <a:srgbClr val="102A43"/>
-          </a:solidFill>
-          <a:ln w="12700">
-            <a:solidFill>
-              <a:srgbClr val="102A43"/>
-            </a:solidFill>
-            <a:prstDash val="solid"/>
-          </a:ln>
-        </p:spPr>
-      </p:sp>
-      <p:sp>
-        <p:nvSpPr>
-          <p:cNvPr id="32" name="Text 29"/>
-          <p:cNvSpPr/>
-          <p:nvPr/>
-        </p:nvSpPr>
-        <p:spPr>
-          <a:xfrm>
-            <a:off x="6409944" y="4288536"/>
-            <a:ext cx="3502152" cy="164592"/>
-          </a:xfrm>
-          <a:prstGeom prst="rect">
-            <a:avLst/>
-          </a:prstGeom>
-          <a:noFill/>
-          <a:ln/>
-        </p:spPr>
-        <p:txBody>
-          <a:bodyPr wrap="square" lIns="0" tIns="0" rIns="0" bIns="0" rtlCol="0" anchor="ctr"/>
-          <a:lstStyle/>
-          <a:p>
-            <a:pPr indent="0" marL="0">
-              <a:buNone/>
-            </a:pPr>
-            <a:r>
-              <a:rPr lang="en-US" sz="1360" b="1" dirty="0">
-                <a:solidFill>
-                  <a:srgbClr val="102A43"/>
-                </a:solidFill>
-                <a:latin typeface="Aptos Display" pitchFamily="34" charset="0"/>
-                <a:ea typeface="Aptos Display" pitchFamily="34" charset="-122"/>
-                <a:cs typeface="Aptos Display" pitchFamily="34" charset="-120"/>
-              </a:rPr>
-              <a:t>Supabase (B4)</a:t>
-            </a:r>
-            <a:endParaRPr lang="en-US" sz="1360" dirty="0"/>
-          </a:p>
-        </p:txBody>
-      </p:sp>
-      <p:sp>
-        <p:nvSpPr>
-          <p:cNvPr id="33" name="Text 30"/>
-          <p:cNvSpPr/>
-          <p:nvPr/>
-        </p:nvSpPr>
-        <p:spPr>
-          <a:xfrm>
-            <a:off x="6409944" y="4581144"/>
-            <a:ext cx="3502152" cy="320040"/>
-          </a:xfrm>
-          <a:prstGeom prst="rect">
-            <a:avLst/>
-          </a:prstGeom>
-          <a:noFill/>
-          <a:ln/>
-        </p:spPr>
-        <p:txBody>
-          <a:bodyPr wrap="square" lIns="0" tIns="0" rIns="0" bIns="0" rtlCol="0" anchor="t"/>
-          <a:lstStyle/>
-          <a:p>
-            <a:pPr indent="0" marL="0">
-              <a:buNone/>
-            </a:pPr>
-            <a:r>
-              <a:rPr lang="en-US" sz="1060" dirty="0">
-                <a:solidFill>
-                  <a:srgbClr val="243B53"/>
-                </a:solidFill>
-                <a:latin typeface="Aptos" pitchFamily="34" charset="0"/>
-                <a:ea typeface="Aptos" pitchFamily="34" charset="-122"/>
-                <a:cs typeface="Aptos" pitchFamily="34" charset="-120"/>
-              </a:rPr>
-              <a:t>Implementamos el CRUD en la nube con FastAPI.</a:t>
-            </a:r>
-            <a:endParaRPr lang="en-US" sz="1060" dirty="0"/>
-          </a:p>
-        </p:txBody>
-      </p:sp>
-      <p:sp>
-        <p:nvSpPr>
-          <p:cNvPr id="34" name="Shape 31"/>
-          <p:cNvSpPr/>
-          <p:nvPr/>
-        </p:nvSpPr>
-        <p:spPr>
-          <a:xfrm>
-            <a:off x="804672" y="5486400"/>
-            <a:ext cx="9381744" cy="548640"/>
-          </a:xfrm>
-          <a:prstGeom prst="roundRect">
-            <a:avLst>
-              <a:gd name="adj" fmla="val 5000"/>
-            </a:avLst>
-          </a:prstGeom>
-          <a:solidFill>
-            <a:srgbClr val="FFFFFF"/>
-          </a:solidFill>
-          <a:ln w="12700">
-            <a:solidFill>
-              <a:srgbClr val="D8CFC4"/>
-            </a:solidFill>
-            <a:prstDash val="solid"/>
-          </a:ln>
-        </p:spPr>
-      </p:sp>
-      <p:sp>
-        <p:nvSpPr>
-          <p:cNvPr id="35" name="Shape 32"/>
-          <p:cNvSpPr/>
-          <p:nvPr/>
-        </p:nvSpPr>
-        <p:spPr>
-          <a:xfrm>
-            <a:off x="877824" y="5596128"/>
-            <a:ext cx="100584" cy="329184"/>
-          </a:xfrm>
-          <a:prstGeom prst="rect">
-            <a:avLst/>
-          </a:prstGeom>
-          <a:solidFill>
-            <a:srgbClr val="E0BC5A"/>
-          </a:solidFill>
-          <a:ln w="12700">
-            <a:solidFill>
-              <a:srgbClr val="E0BC5A"/>
-            </a:solidFill>
-            <a:prstDash val="solid"/>
-          </a:ln>
-        </p:spPr>
-      </p:sp>
-      <p:sp>
-        <p:nvSpPr>
-          <p:cNvPr id="36" name="Text 33"/>
-          <p:cNvSpPr/>
-          <p:nvPr/>
-        </p:nvSpPr>
-        <p:spPr>
-          <a:xfrm>
-            <a:off x="1060704" y="5614416"/>
-            <a:ext cx="9052560" cy="219456"/>
-          </a:xfrm>
-          <a:prstGeom prst="rect">
-            <a:avLst/>
-          </a:prstGeom>
-          <a:noFill/>
-          <a:ln/>
-        </p:spPr>
-        <p:txBody>
-          <a:bodyPr wrap="square" lIns="0" tIns="0" rIns="0" bIns="0" rtlCol="0" anchor="ctr"/>
-          <a:lstStyle/>
-          <a:p>
-            <a:pPr indent="0" marL="0">
-              <a:buNone/>
-            </a:pPr>
-            <a:r>
-              <a:rPr lang="en-US" sz="1100" b="1" dirty="0">
-                <a:solidFill>
-                  <a:srgbClr val="102A43"/>
-                </a:solidFill>
-                <a:latin typeface="Aptos Display" pitchFamily="34" charset="0"/>
-                <a:ea typeface="Aptos Display" pitchFamily="34" charset="-122"/>
-                <a:cs typeface="Aptos Display" pitchFamily="34" charset="-120"/>
-              </a:rPr>
-              <a:t>Próximo Paso</a:t>
-            </a:r>
-            <a:endParaRPr lang="en-US" sz="1100" dirty="0"/>
+              <a:t>Nos vemos en la Clase 03</a:t>
+            </a:r>
+            <a:endParaRPr lang="en-US" sz="2400" dirty="0"/>
           </a:p>
         </p:txBody>
       </p:sp>

</xml_diff>